<commit_message>
Expand lesson 1 & 2 to fill 90 min + AI-track bridges; update master content-generation prompt
</commit_message>
<xml_diff>
--- a/lesson_01/lesson_01_slides.pptx
+++ b/lesson_01/lesson_01_slides.pptx
@@ -16,9 +16,10 @@
     <p:sldId id="264" r:id="rId10"/>
     <p:sldId id="265" r:id="rId11"/>
     <p:sldId id="266" r:id="rId12"/>
+    <p:sldId id="267" r:id="rId13"/>
   </p:sldIdLst>
   <p:notesMasterIdLst>
-    <p:notesMasterId r:id="rId13"/>
+    <p:notesMasterId r:id="rId14"/>
   </p:notesMasterIdLst>
   <p:sldSz cx="12192000" cy="6858000"/>
   <p:notesSz cx="6858000" cy="12192000"/>
@@ -712,6 +713,94 @@
             <a:fld id="{F7021451-1387-4CA6-816F-3879F97B5CBC}" type="slidenum">
               <a:rPr lang="en-US"/>
               <a:t>11</a:t>
+            </a:fld>
+            <a:endParaRPr lang="en-US"/>
+          </a:p>
+        </p:txBody>
+      </p:sp>
+    </p:spTree>
+    <p:extLst>
+      <p:ext uri="{BB962C8B-B14F-4D97-AF65-F5344CB8AC3E}">
+        <p14:creationId xmlns:p14="http://schemas.microsoft.com/office/powerpoint/2010/main" val="1024086991"/>
+      </p:ext>
+    </p:extLst>
+  </p:cSld>
+  <p:clrMapOvr>
+    <a:masterClrMapping/>
+  </p:clrMapOvr>
+</p:notes>
+</file>
+
+<file path=ppt/notesSlides/notesSlide12.xml><?xml version="1.0" encoding="utf-8"?>
+<p:notes xmlns:a="http://schemas.openxmlformats.org/drawingml/2006/main" xmlns:r="http://schemas.openxmlformats.org/officeDocument/2006/relationships" xmlns:p="http://schemas.openxmlformats.org/presentationml/2006/main">
+  <p:cSld>
+    <p:spTree>
+      <p:nvGrpSpPr>
+        <p:cNvPr id="1" name=""/>
+        <p:cNvGrpSpPr/>
+        <p:nvPr/>
+      </p:nvGrpSpPr>
+      <p:grpSpPr>
+        <a:xfrm>
+          <a:off x="0" y="0"/>
+          <a:ext cx="0" cy="0"/>
+          <a:chOff x="0" y="0"/>
+          <a:chExt cx="0" cy="0"/>
+        </a:xfrm>
+      </p:grpSpPr>
+      <p:sp>
+        <p:nvSpPr>
+          <p:cNvPr id="2" name="Slide Image Placeholder 1"/>
+          <p:cNvSpPr>
+            <a:spLocks noGrp="1" noRot="1" noChangeAspect="1"/>
+          </p:cNvSpPr>
+          <p:nvPr>
+            <p:ph type="sldImg"/>
+          </p:nvPr>
+        </p:nvSpPr>
+        <p:spPr/>
+      </p:sp>
+      <p:sp>
+        <p:nvSpPr>
+          <p:cNvPr id="3" name="Notes Placeholder 2"/>
+          <p:cNvSpPr>
+            <a:spLocks noGrp="1"/>
+          </p:cNvSpPr>
+          <p:nvPr>
+            <p:ph type="body" idx="1"/>
+          </p:nvPr>
+        </p:nvSpPr>
+        <p:spPr/>
+        <p:txBody>
+          <a:bodyPr/>
+          <a:lstStyle/>
+          <a:p>
+            <a:r>
+              <a:rPr lang="en-US" dirty="0"/>
+              <a:t/>
+            </a:r>
+            <a:endParaRPr lang="en-US" dirty="0"/>
+          </a:p>
+        </p:txBody>
+      </p:sp>
+      <p:sp>
+        <p:nvSpPr>
+          <p:cNvPr id="4" name="Slide Number Placeholder 3"/>
+          <p:cNvSpPr>
+            <a:spLocks noGrp="1"/>
+          </p:cNvSpPr>
+          <p:nvPr>
+            <p:ph type="sldNum" sz="quarter" idx="10"/>
+          </p:nvPr>
+        </p:nvSpPr>
+        <p:spPr/>
+        <p:txBody>
+          <a:bodyPr/>
+          <a:lstStyle/>
+          <a:p>
+            <a:fld id="{F7021451-1387-4CA6-816F-3879F97B5CBC}" type="slidenum">
+              <a:rPr lang="en-US"/>
+              <a:t>12</a:t>
             </a:fld>
             <a:endParaRPr lang="en-US"/>
           </a:p>
@@ -2140,6 +2229,258 @@
     <p:bg>
       <p:bgPr>
         <a:solidFill>
+          <a:srgbClr val="1B1F3B"/>
+        </a:solidFill>
+      </p:bgPr>
+    </p:bg>
+    <p:spTree>
+      <p:nvGrpSpPr>
+        <p:cNvPr id="1" name=""/>
+        <p:cNvGrpSpPr/>
+        <p:nvPr/>
+      </p:nvGrpSpPr>
+      <p:grpSpPr>
+        <a:xfrm>
+          <a:off x="0" y="0"/>
+          <a:ext cx="0" cy="0"/>
+          <a:chOff x="0" y="0"/>
+          <a:chExt cx="0" cy="0"/>
+        </a:xfrm>
+      </p:grpSpPr>
+      <p:sp>
+        <p:nvSpPr>
+          <p:cNvPr id="2" name="Text 0"/>
+          <p:cNvSpPr/>
+          <p:nvPr/>
+        </p:nvSpPr>
+        <p:spPr>
+          <a:xfrm>
+            <a:off x="548640" y="457200"/>
+            <a:ext cx="11091672" cy="548640"/>
+          </a:xfrm>
+          <a:prstGeom prst="rect">
+            <a:avLst/>
+          </a:prstGeom>
+          <a:noFill/>
+          <a:ln/>
+        </p:spPr>
+        <p:txBody>
+          <a:bodyPr wrap="square" lIns="0" tIns="0" rIns="0" bIns="0" rtlCol="0" anchor="ctr"/>
+          <a:lstStyle/>
+          <a:p>
+            <a:pPr algn="ctr" indent="0" marL="0">
+              <a:buNone/>
+            </a:pPr>
+            <a:r>
+              <a:rPr lang="en-US" sz="1600" i="1" dirty="0">
+                <a:solidFill>
+                  <a:srgbClr val="00C2A8"/>
+                </a:solidFill>
+                <a:latin typeface="Calibri" pitchFamily="34" charset="0"/>
+                <a:ea typeface="Calibri" pitchFamily="34" charset="-122"/>
+                <a:cs typeface="Calibri" pitchFamily="34" charset="-120"/>
+              </a:rPr>
+              <a:t>הדגמה חיה</a:t>
+            </a:r>
+            <a:endParaRPr lang="en-US" sz="1600" dirty="0"/>
+          </a:p>
+        </p:txBody>
+      </p:sp>
+      <p:sp>
+        <p:nvSpPr>
+          <p:cNvPr id="3" name="Text 1"/>
+          <p:cNvSpPr/>
+          <p:nvPr/>
+        </p:nvSpPr>
+        <p:spPr>
+          <a:xfrm>
+            <a:off x="548640" y="1097280"/>
+            <a:ext cx="11091672" cy="1097280"/>
+          </a:xfrm>
+          <a:prstGeom prst="rect">
+            <a:avLst/>
+          </a:prstGeom>
+          <a:noFill/>
+          <a:ln/>
+        </p:spPr>
+        <p:txBody>
+          <a:bodyPr wrap="square" lIns="0" tIns="0" rIns="0" bIns="0" rtlCol="0" anchor="ctr"/>
+          <a:lstStyle/>
+          <a:p>
+            <a:pPr rtl="1" algn="ctr" indent="0" marL="0">
+              <a:buNone/>
+            </a:pPr>
+            <a:r>
+              <a:rPr lang="en-US" sz="3800" b="1" dirty="0">
+                <a:solidFill>
+                  <a:srgbClr val="FFFFFF"/>
+                </a:solidFill>
+                <a:latin typeface="Arial" pitchFamily="34" charset="0"/>
+                <a:ea typeface="Arial" pitchFamily="34" charset="-122"/>
+                <a:cs typeface="Arial" pitchFamily="34" charset="-120"/>
+              </a:rPr>
+              <a:t>20 דקות. בונים יחד, בזמן אמת.</a:t>
+            </a:r>
+            <a:endParaRPr lang="en-US" sz="3800" dirty="0"/>
+          </a:p>
+        </p:txBody>
+      </p:sp>
+      <p:sp>
+        <p:nvSpPr>
+          <p:cNvPr id="4" name="Text 2"/>
+          <p:cNvSpPr/>
+          <p:nvPr/>
+        </p:nvSpPr>
+        <p:spPr>
+          <a:xfrm>
+            <a:off x="548640" y="2148840"/>
+            <a:ext cx="11091672" cy="457200"/>
+          </a:xfrm>
+          <a:prstGeom prst="rect">
+            <a:avLst/>
+          </a:prstGeom>
+          <a:noFill/>
+          <a:ln/>
+        </p:spPr>
+        <p:txBody>
+          <a:bodyPr wrap="square" lIns="0" tIns="0" rIns="0" bIns="0" rtlCol="0" anchor="ctr"/>
+          <a:lstStyle/>
+          <a:p>
+            <a:pPr rtl="1" algn="ctr" indent="0" marL="0">
+              <a:buNone/>
+            </a:pPr>
+            <a:r>
+              <a:rPr lang="en-US" sz="1500" i="1" dirty="0">
+                <a:solidFill>
+                  <a:srgbClr val="CADCFC"/>
+                </a:solidFill>
+                <a:latin typeface="Calibri" pitchFamily="34" charset="0"/>
+                <a:ea typeface="Calibri" pitchFamily="34" charset="-122"/>
+                <a:cs typeface="Calibri" pitchFamily="34" charset="-120"/>
+              </a:rPr>
+              <a:t>ראו demo/prompt.md להוראות המלאות</a:t>
+            </a:r>
+            <a:endParaRPr lang="en-US" sz="1500" dirty="0"/>
+          </a:p>
+        </p:txBody>
+      </p:sp>
+      <p:sp>
+        <p:nvSpPr>
+          <p:cNvPr id="5" name="Shape 3"/>
+          <p:cNvSpPr/>
+          <p:nvPr/>
+        </p:nvSpPr>
+        <p:spPr>
+          <a:xfrm>
+            <a:off x="3200400" y="2880360"/>
+            <a:ext cx="5788152" cy="3291840"/>
+          </a:xfrm>
+          <a:prstGeom prst="rect">
+            <a:avLst/>
+          </a:prstGeom>
+          <a:solidFill>
+            <a:srgbClr val="2A2F55"/>
+          </a:solidFill>
+          <a:ln w="15875">
+            <a:solidFill>
+              <a:srgbClr val="00C2A8"/>
+            </a:solidFill>
+            <a:prstDash val="dash"/>
+          </a:ln>
+        </p:spPr>
+      </p:sp>
+      <p:sp>
+        <p:nvSpPr>
+          <p:cNvPr id="6" name="Text 4"/>
+          <p:cNvSpPr/>
+          <p:nvPr/>
+        </p:nvSpPr>
+        <p:spPr>
+          <a:xfrm>
+            <a:off x="3200400" y="2880360"/>
+            <a:ext cx="5788152" cy="3291840"/>
+          </a:xfrm>
+          <a:prstGeom prst="rect">
+            <a:avLst/>
+          </a:prstGeom>
+          <a:noFill/>
+          <a:ln/>
+        </p:spPr>
+        <p:txBody>
+          <a:bodyPr wrap="square" lIns="101600" tIns="101600" rIns="101600" bIns="101600" rtlCol="0" anchor="ctr"/>
+          <a:lstStyle/>
+          <a:p>
+            <a:pPr rtl="1" algn="ctr" indent="0" marL="0">
+              <a:buNone/>
+            </a:pPr>
+            <a:r>
+              <a:rPr lang="en-US" sz="1200" i="1" dirty="0">
+                <a:solidFill>
+                  <a:srgbClr val="00C2A8"/>
+                </a:solidFill>
+                <a:latin typeface="Calibri" pitchFamily="34" charset="0"/>
+                <a:ea typeface="Calibri" pitchFamily="34" charset="-122"/>
+                <a:cs typeface="Calibri" pitchFamily="34" charset="-120"/>
+              </a:rPr>
+              <a:t>[תמונה: מסך שיתוף / הקלטת מסך של סוכן AI בונה קוד בזמן אמת]</a:t>
+            </a:r>
+            <a:endParaRPr lang="en-US" sz="1200" dirty="0"/>
+          </a:p>
+        </p:txBody>
+      </p:sp>
+      <p:sp>
+        <p:nvSpPr>
+          <p:cNvPr id="7" name="Text 5"/>
+          <p:cNvSpPr/>
+          <p:nvPr/>
+        </p:nvSpPr>
+        <p:spPr>
+          <a:xfrm>
+            <a:off x="548640" y="6492240"/>
+            <a:ext cx="11091672" cy="274320"/>
+          </a:xfrm>
+          <a:prstGeom prst="rect">
+            <a:avLst/>
+          </a:prstGeom>
+          <a:noFill/>
+          <a:ln/>
+        </p:spPr>
+        <p:txBody>
+          <a:bodyPr wrap="square" lIns="0" tIns="0" rIns="0" bIns="0" rtlCol="0" anchor="ctr"/>
+          <a:lstStyle/>
+          <a:p>
+            <a:pPr rtl="1" algn="r" indent="0" marL="0">
+              <a:buNone/>
+            </a:pPr>
+            <a:r>
+              <a:rPr lang="en-US" sz="900" dirty="0">
+                <a:solidFill>
+                  <a:srgbClr val="8891C2"/>
+                </a:solidFill>
+                <a:latin typeface="Calibri" pitchFamily="34" charset="0"/>
+                <a:ea typeface="Calibri" pitchFamily="34" charset="-122"/>
+                <a:cs typeface="Calibri" pitchFamily="34" charset="-120"/>
+              </a:rPr>
+              <a:t>Vibe Coding · שיעור 1 · שקף 10</a:t>
+            </a:r>
+            <a:endParaRPr lang="en-US" sz="900" dirty="0"/>
+          </a:p>
+        </p:txBody>
+      </p:sp>
+    </p:spTree>
+  </p:cSld>
+  <p:clrMapOvr>
+    <a:masterClrMapping/>
+  </p:clrMapOvr>
+</p:sld>
+</file>
+
+<file path=ppt/slides/slide11.xml><?xml version="1.0" encoding="utf-8"?>
+<p:sld xmlns:a="http://schemas.openxmlformats.org/drawingml/2006/main" xmlns:r="http://schemas.openxmlformats.org/officeDocument/2006/relationships" xmlns:p="http://schemas.openxmlformats.org/presentationml/2006/main">
+  <p:cSld name="Slide 11">
+    <p:bg>
+      <p:bgPr>
+        <a:solidFill>
           <a:srgbClr val="00C2A8"/>
         </a:solidFill>
       </p:bgPr>
@@ -2449,9 +2790,9 @@
 </p:sld>
 </file>
 
-<file path=ppt/slides/slide11.xml><?xml version="1.0" encoding="utf-8"?>
+<file path=ppt/slides/slide12.xml><?xml version="1.0" encoding="utf-8"?>
 <p:sld xmlns:a="http://schemas.openxmlformats.org/drawingml/2006/main" xmlns:r="http://schemas.openxmlformats.org/officeDocument/2006/relationships" xmlns:p="http://schemas.openxmlformats.org/presentationml/2006/main">
-  <p:cSld name="Slide 11">
+  <p:cSld name="Slide 12">
     <p:bg>
       <p:bgPr>
         <a:solidFill>
@@ -8212,7 +8553,7 @@
     <p:bg>
       <p:bgPr>
         <a:solidFill>
-          <a:srgbClr val="1B1F3B"/>
+          <a:srgbClr val="FFFFFF"/>
         </a:solidFill>
       </p:bgPr>
     </p:bg>
@@ -8238,8 +8579,89 @@
         </p:nvSpPr>
         <p:spPr>
           <a:xfrm>
-            <a:off x="548640" y="457200"/>
-            <a:ext cx="11091672" cy="548640"/>
+            <a:off x="548640" y="365760"/>
+            <a:ext cx="11091672" cy="822960"/>
+          </a:xfrm>
+          <a:prstGeom prst="rect">
+            <a:avLst/>
+          </a:prstGeom>
+          <a:noFill/>
+          <a:ln/>
+        </p:spPr>
+        <p:txBody>
+          <a:bodyPr wrap="square" lIns="0" tIns="0" rIns="0" bIns="0" rtlCol="0" anchor="ctr"/>
+          <a:lstStyle/>
+          <a:p>
+            <a:pPr rtl="1" algn="r" indent="0" marL="0">
+              <a:buNone/>
+            </a:pPr>
+            <a:r>
+              <a:rPr lang="en-US" sz="3000" b="1" dirty="0">
+                <a:solidFill>
+                  <a:srgbClr val="1B1F3B"/>
+                </a:solidFill>
+                <a:latin typeface="Arial" pitchFamily="34" charset="0"/>
+                <a:ea typeface="Arial" pitchFamily="34" charset="-122"/>
+                <a:cs typeface="Arial" pitchFamily="34" charset="-120"/>
+              </a:rPr>
+              <a:t>עוד דוגמה: זה לא רק Google</a:t>
+            </a:r>
+            <a:endParaRPr lang="en-US" sz="3000" dirty="0"/>
+          </a:p>
+        </p:txBody>
+      </p:sp>
+      <p:sp>
+        <p:nvSpPr>
+          <p:cNvPr id="3" name="Shape 1"/>
+          <p:cNvSpPr/>
+          <p:nvPr/>
+        </p:nvSpPr>
+        <p:spPr>
+          <a:xfrm>
+            <a:off x="548640" y="1645920"/>
+            <a:ext cx="11091672" cy="2286000"/>
+          </a:xfrm>
+          <a:prstGeom prst="roundRect">
+            <a:avLst>
+              <a:gd name="adj" fmla="val 4000"/>
+            </a:avLst>
+          </a:prstGeom>
+          <a:solidFill>
+            <a:srgbClr val="FFF6E6"/>
+          </a:solidFill>
+          <a:ln/>
+        </p:spPr>
+      </p:sp>
+      <p:sp>
+        <p:nvSpPr>
+          <p:cNvPr id="4" name="Shape 2"/>
+          <p:cNvSpPr/>
+          <p:nvPr/>
+        </p:nvSpPr>
+        <p:spPr>
+          <a:xfrm>
+            <a:off x="10332720" y="1828800"/>
+            <a:ext cx="457200" cy="457200"/>
+          </a:xfrm>
+          <a:prstGeom prst="ellipse">
+            <a:avLst/>
+          </a:prstGeom>
+          <a:solidFill>
+            <a:srgbClr val="FFB000"/>
+          </a:solidFill>
+          <a:ln/>
+        </p:spPr>
+      </p:sp>
+      <p:sp>
+        <p:nvSpPr>
+          <p:cNvPr id="5" name="Text 3"/>
+          <p:cNvSpPr/>
+          <p:nvPr/>
+        </p:nvSpPr>
+        <p:spPr>
+          <a:xfrm>
+            <a:off x="10332720" y="1828800"/>
+            <a:ext cx="457200" cy="457200"/>
           </a:xfrm>
           <a:prstGeom prst="rect">
             <a:avLst/>
@@ -8255,165 +8677,205 @@
               <a:buNone/>
             </a:pPr>
             <a:r>
-              <a:rPr lang="en-US" sz="1600" i="1" dirty="0">
-                <a:solidFill>
-                  <a:srgbClr val="00C2A8"/>
+              <a:rPr lang="en-US" sz="1400" b="1" dirty="0">
+                <a:solidFill>
+                  <a:srgbClr val="FFFFFF"/>
+                </a:solidFill>
+                <a:latin typeface="Arial" pitchFamily="34" charset="0"/>
+                <a:ea typeface="Arial" pitchFamily="34" charset="-122"/>
+                <a:cs typeface="Arial" pitchFamily="34" charset="-120"/>
+              </a:rPr>
+              <a:t>!</a:t>
+            </a:r>
+            <a:endParaRPr lang="en-US" sz="1400" dirty="0"/>
+          </a:p>
+        </p:txBody>
+      </p:sp>
+      <p:sp>
+        <p:nvSpPr>
+          <p:cNvPr id="6" name="Text 4"/>
+          <p:cNvSpPr/>
+          <p:nvPr/>
+        </p:nvSpPr>
+        <p:spPr>
+          <a:xfrm>
+            <a:off x="822960" y="1920240"/>
+            <a:ext cx="9326880" cy="1828800"/>
+          </a:xfrm>
+          <a:prstGeom prst="rect">
+            <a:avLst/>
+          </a:prstGeom>
+          <a:noFill/>
+          <a:ln/>
+        </p:spPr>
+        <p:txBody>
+          <a:bodyPr wrap="square" lIns="0" tIns="0" rIns="0" bIns="0" rtlCol="0" anchor="ctr"/>
+          <a:lstStyle/>
+          <a:p>
+            <a:pPr algn="r" indent="0" marL="0">
+              <a:spcAft>
+                <a:spcPts val="1000"/>
+              </a:spcAft>
+              <a:buNone/>
+            </a:pPr>
+            <a:r>
+              <a:rPr lang="en-US" sz="1500" dirty="0">
+                <a:solidFill>
+                  <a:srgbClr val="1B1F3B"/>
                 </a:solidFill>
                 <a:latin typeface="Calibri" pitchFamily="34" charset="0"/>
                 <a:ea typeface="Calibri" pitchFamily="34" charset="-122"/>
                 <a:cs typeface="Calibri" pitchFamily="34" charset="-120"/>
               </a:rPr>
-              <a:t>הדגמה חיה</a:t>
-            </a:r>
-            <a:endParaRPr lang="en-US" sz="1600" dirty="0"/>
-          </a:p>
-        </p:txBody>
-      </p:sp>
-      <p:sp>
-        <p:nvSpPr>
-          <p:cNvPr id="3" name="Text 1"/>
-          <p:cNvSpPr/>
-          <p:nvPr/>
-        </p:nvSpPr>
-        <p:spPr>
-          <a:xfrm>
-            <a:off x="548640" y="1097280"/>
-            <a:ext cx="11091672" cy="1097280"/>
-          </a:xfrm>
-          <a:prstGeom prst="rect">
-            <a:avLst/>
-          </a:prstGeom>
-          <a:noFill/>
-          <a:ln/>
-        </p:spPr>
-        <p:txBody>
-          <a:bodyPr wrap="square" lIns="0" tIns="0" rIns="0" bIns="0" rtlCol="0" anchor="ctr"/>
-          <a:lstStyle/>
-          <a:p>
-            <a:pPr rtl="1" algn="ctr" indent="0" marL="0">
-              <a:buNone/>
-            </a:pPr>
-            <a:r>
-              <a:rPr lang="en-US" sz="3800" b="1" dirty="0">
-                <a:solidFill>
-                  <a:srgbClr val="FFFFFF"/>
+              <a:t>• מרץ 2026: GitHub שינה את מסלול הסטודנטים ל-Copilot Student</a:t>
+            </a:r>
+            <a:endParaRPr lang="en-US" sz="1500" dirty="0"/>
+          </a:p>
+          <a:p>
+            <a:pPr algn="r" indent="0" marL="0">
+              <a:spcAft>
+                <a:spcPts val="1000"/>
+              </a:spcAft>
+              <a:buNone/>
+            </a:pPr>
+            <a:r>
+              <a:rPr lang="en-US" sz="1500" dirty="0">
+                <a:solidFill>
+                  <a:srgbClr val="1B1F3B"/>
+                </a:solidFill>
+                <a:latin typeface="Calibri" pitchFamily="34" charset="0"/>
+                <a:ea typeface="Calibri" pitchFamily="34" charset="-122"/>
+                <a:cs typeface="Calibri" pitchFamily="34" charset="-120"/>
+              </a:rPr>
+              <a:t>• הפעלות חדשות מוקפאות זמנית — בלי לוח זמנים לחידוש</a:t>
+            </a:r>
+            <a:endParaRPr lang="en-US" sz="1500" dirty="0"/>
+          </a:p>
+          <a:p>
+            <a:pPr algn="r" indent="0" marL="0">
+              <a:spcAft>
+                <a:spcPts val="1000"/>
+              </a:spcAft>
+              <a:buNone/>
+            </a:pPr>
+            <a:r>
+              <a:rPr lang="en-US" sz="1500" dirty="0">
+                <a:solidFill>
+                  <a:srgbClr val="1B1F3B"/>
+                </a:solidFill>
+                <a:latin typeface="Calibri" pitchFamily="34" charset="0"/>
+                <a:ea typeface="Calibri" pitchFamily="34" charset="-122"/>
+                <a:cs typeface="Calibri" pitchFamily="34" charset="-120"/>
+              </a:rPr>
+              <a:t>• גם ״תנאי מסלול חינם״ משתנים בלי אזהרה, לא רק כלים שלמים</a:t>
+            </a:r>
+            <a:endParaRPr lang="en-US" sz="1500" dirty="0"/>
+          </a:p>
+        </p:txBody>
+      </p:sp>
+      <p:sp>
+        <p:nvSpPr>
+          <p:cNvPr id="7" name="Shape 5"/>
+          <p:cNvSpPr/>
+          <p:nvPr/>
+        </p:nvSpPr>
+        <p:spPr>
+          <a:xfrm>
+            <a:off x="548640" y="4206240"/>
+            <a:ext cx="11091672" cy="1371600"/>
+          </a:xfrm>
+          <a:prstGeom prst="roundRect">
+            <a:avLst>
+              <a:gd name="adj" fmla="val 6667"/>
+            </a:avLst>
+          </a:prstGeom>
+          <a:solidFill>
+            <a:srgbClr val="E6FBF7"/>
+          </a:solidFill>
+          <a:ln/>
+        </p:spPr>
+      </p:sp>
+      <p:sp>
+        <p:nvSpPr>
+          <p:cNvPr id="8" name="Text 6"/>
+          <p:cNvSpPr/>
+          <p:nvPr/>
+        </p:nvSpPr>
+        <p:spPr>
+          <a:xfrm>
+            <a:off x="822960" y="4370832"/>
+            <a:ext cx="10543032" cy="365760"/>
+          </a:xfrm>
+          <a:prstGeom prst="rect">
+            <a:avLst/>
+          </a:prstGeom>
+          <a:noFill/>
+          <a:ln/>
+        </p:spPr>
+        <p:txBody>
+          <a:bodyPr wrap="square" lIns="0" tIns="0" rIns="0" bIns="0" rtlCol="0" anchor="ctr"/>
+          <a:lstStyle/>
+          <a:p>
+            <a:pPr rtl="1" algn="r" indent="0" marL="0">
+              <a:buNone/>
+            </a:pPr>
+            <a:r>
+              <a:rPr lang="en-US" sz="1300" i="1" dirty="0">
+                <a:solidFill>
+                  <a:srgbClr val="00C2A8"/>
+                </a:solidFill>
+                <a:latin typeface="Calibri" pitchFamily="34" charset="0"/>
+                <a:ea typeface="Calibri" pitchFamily="34" charset="-122"/>
+                <a:cs typeface="Calibri" pitchFamily="34" charset="-120"/>
+              </a:rPr>
+              <a:t>פעילות זוגות</a:t>
+            </a:r>
+            <a:endParaRPr lang="en-US" sz="1300" dirty="0"/>
+          </a:p>
+        </p:txBody>
+      </p:sp>
+      <p:sp>
+        <p:nvSpPr>
+          <p:cNvPr id="9" name="Text 7"/>
+          <p:cNvSpPr/>
+          <p:nvPr/>
+        </p:nvSpPr>
+        <p:spPr>
+          <a:xfrm>
+            <a:off x="822960" y="4663440"/>
+            <a:ext cx="10543032" cy="822960"/>
+          </a:xfrm>
+          <a:prstGeom prst="rect">
+            <a:avLst/>
+          </a:prstGeom>
+          <a:noFill/>
+          <a:ln/>
+        </p:spPr>
+        <p:txBody>
+          <a:bodyPr wrap="square" lIns="0" tIns="0" rIns="0" bIns="0" rtlCol="0" anchor="ctr"/>
+          <a:lstStyle/>
+          <a:p>
+            <a:pPr rtl="1" algn="r" indent="0" marL="0">
+              <a:buNone/>
+            </a:pPr>
+            <a:r>
+              <a:rPr lang="en-US" sz="1600" b="1" dirty="0">
+                <a:solidFill>
+                  <a:srgbClr val="1B1F3B"/>
                 </a:solidFill>
                 <a:latin typeface="Arial" pitchFamily="34" charset="0"/>
                 <a:ea typeface="Arial" pitchFamily="34" charset="-122"/>
                 <a:cs typeface="Arial" pitchFamily="34" charset="-120"/>
               </a:rPr>
-              <a:t>20 דקות. בונים יחד, בזמן אמת.</a:t>
-            </a:r>
-            <a:endParaRPr lang="en-US" sz="3800" dirty="0"/>
-          </a:p>
-        </p:txBody>
-      </p:sp>
-      <p:sp>
-        <p:nvSpPr>
-          <p:cNvPr id="4" name="Text 2"/>
-          <p:cNvSpPr/>
-          <p:nvPr/>
-        </p:nvSpPr>
-        <p:spPr>
-          <a:xfrm>
-            <a:off x="548640" y="2148840"/>
-            <a:ext cx="11091672" cy="457200"/>
-          </a:xfrm>
-          <a:prstGeom prst="rect">
-            <a:avLst/>
-          </a:prstGeom>
-          <a:noFill/>
-          <a:ln/>
-        </p:spPr>
-        <p:txBody>
-          <a:bodyPr wrap="square" lIns="0" tIns="0" rIns="0" bIns="0" rtlCol="0" anchor="ctr"/>
-          <a:lstStyle/>
-          <a:p>
-            <a:pPr rtl="1" algn="ctr" indent="0" marL="0">
-              <a:buNone/>
-            </a:pPr>
-            <a:r>
-              <a:rPr lang="en-US" sz="1500" i="1" dirty="0">
-                <a:solidFill>
-                  <a:srgbClr val="CADCFC"/>
-                </a:solidFill>
-                <a:latin typeface="Calibri" pitchFamily="34" charset="0"/>
-                <a:ea typeface="Calibri" pitchFamily="34" charset="-122"/>
-                <a:cs typeface="Calibri" pitchFamily="34" charset="-120"/>
-              </a:rPr>
-              <a:t>ראו demo/prompt.md להוראות המלאות</a:t>
-            </a:r>
-            <a:endParaRPr lang="en-US" sz="1500" dirty="0"/>
-          </a:p>
-        </p:txBody>
-      </p:sp>
-      <p:sp>
-        <p:nvSpPr>
-          <p:cNvPr id="5" name="Shape 3"/>
-          <p:cNvSpPr/>
-          <p:nvPr/>
-        </p:nvSpPr>
-        <p:spPr>
-          <a:xfrm>
-            <a:off x="3200400" y="2880360"/>
-            <a:ext cx="5788152" cy="3291840"/>
-          </a:xfrm>
-          <a:prstGeom prst="rect">
-            <a:avLst/>
-          </a:prstGeom>
-          <a:solidFill>
-            <a:srgbClr val="2A2F55"/>
-          </a:solidFill>
-          <a:ln w="15875">
-            <a:solidFill>
-              <a:srgbClr val="00C2A8"/>
-            </a:solidFill>
-            <a:prstDash val="dash"/>
-          </a:ln>
-        </p:spPr>
-      </p:sp>
-      <p:sp>
-        <p:nvSpPr>
-          <p:cNvPr id="6" name="Text 4"/>
-          <p:cNvSpPr/>
-          <p:nvPr/>
-        </p:nvSpPr>
-        <p:spPr>
-          <a:xfrm>
-            <a:off x="3200400" y="2880360"/>
-            <a:ext cx="5788152" cy="3291840"/>
-          </a:xfrm>
-          <a:prstGeom prst="rect">
-            <a:avLst/>
-          </a:prstGeom>
-          <a:noFill/>
-          <a:ln/>
-        </p:spPr>
-        <p:txBody>
-          <a:bodyPr wrap="square" lIns="101600" tIns="101600" rIns="101600" bIns="101600" rtlCol="0" anchor="ctr"/>
-          <a:lstStyle/>
-          <a:p>
-            <a:pPr rtl="1" algn="ctr" indent="0" marL="0">
-              <a:buNone/>
-            </a:pPr>
-            <a:r>
-              <a:rPr lang="en-US" sz="1200" i="1" dirty="0">
-                <a:solidFill>
-                  <a:srgbClr val="00C2A8"/>
-                </a:solidFill>
-                <a:latin typeface="Calibri" pitchFamily="34" charset="0"/>
-                <a:ea typeface="Calibri" pitchFamily="34" charset="-122"/>
-                <a:cs typeface="Calibri" pitchFamily="34" charset="-120"/>
-              </a:rPr>
-              <a:t>[תמונה: מסך שיתוף / הקלטת מסך של סוכן AI בונה קוד בזמן אמת]</a:t>
-            </a:r>
-            <a:endParaRPr lang="en-US" sz="1200" dirty="0"/>
-          </a:p>
-        </p:txBody>
-      </p:sp>
-      <p:sp>
-        <p:nvSpPr>
-          <p:cNvPr id="7" name="Text 5"/>
+              <a:t>תחשבו על כלי טכנולוגי שהשתנה דרמטית בחייכם תוך שנה-שנתיים — שתפו את בן/בת הזוג</a:t>
+            </a:r>
+            <a:endParaRPr lang="en-US" sz="1600" dirty="0"/>
+          </a:p>
+        </p:txBody>
+      </p:sp>
+      <p:sp>
+        <p:nvSpPr>
+          <p:cNvPr id="10" name="Text 8"/>
           <p:cNvSpPr/>
           <p:nvPr/>
         </p:nvSpPr>
@@ -8438,7 +8900,7 @@
             <a:r>
               <a:rPr lang="en-US" sz="900" dirty="0">
                 <a:solidFill>
-                  <a:srgbClr val="8891C2"/>
+                  <a:srgbClr val="A6A6B0"/>
                 </a:solidFill>
                 <a:latin typeface="Calibri" pitchFamily="34" charset="0"/>
                 <a:ea typeface="Calibri" pitchFamily="34" charset="-122"/>

</xml_diff>

<commit_message>
Fix real RTL bug in pptxgenjs decks: rtlMode was only read from the first run's options in rich-text arrays, so every multi-run bullet/question/best-practice paragraph rendered LTR in PowerPoint despite looking fine in LibreOffice QA. Fixed lesson 1 + 2, verified via raw XML rtl=1 count, documented as mandatory build+verification rule in master prompt.
</commit_message>
<xml_diff>
--- a/lesson_01/lesson_01_slides.pptx
+++ b/lesson_01/lesson_01_slides.pptx
@@ -2921,7 +2921,7 @@
           <a:bodyPr wrap="square" lIns="0" tIns="0" rIns="0" bIns="0" rtlCol="0" anchor="ctr"/>
           <a:lstStyle/>
           <a:p>
-            <a:pPr algn="r" indent="0" marL="0">
+            <a:pPr rtl="1" algn="r" indent="0" marL="0">
               <a:spcAft>
                 <a:spcPts val="800"/>
               </a:spcAft>
@@ -2941,7 +2941,7 @@
             <a:endParaRPr lang="en-US" sz="1700" dirty="0"/>
           </a:p>
           <a:p>
-            <a:pPr algn="r" indent="0" marL="0">
+            <a:pPr rtl="1" algn="r" indent="0" marL="0">
               <a:spcAft>
                 <a:spcPts val="800"/>
               </a:spcAft>
@@ -2961,7 +2961,7 @@
             <a:endParaRPr lang="en-US" sz="1700" dirty="0"/>
           </a:p>
           <a:p>
-            <a:pPr algn="r" indent="0" marL="0">
+            <a:pPr rtl="1" algn="r" indent="0" marL="0">
               <a:spcAft>
                 <a:spcPts val="800"/>
               </a:spcAft>
@@ -2981,7 +2981,7 @@
             <a:endParaRPr lang="en-US" sz="1700" dirty="0"/>
           </a:p>
           <a:p>
-            <a:pPr algn="r" indent="0" marL="0">
+            <a:pPr rtl="1" algn="r" indent="0" marL="0">
               <a:spcAft>
                 <a:spcPts val="800"/>
               </a:spcAft>
@@ -3197,7 +3197,7 @@
           <a:bodyPr wrap="square" lIns="0" tIns="0" rIns="0" bIns="0" rtlCol="0" anchor="ctr"/>
           <a:lstStyle/>
           <a:p>
-            <a:pPr algn="r" indent="0" marL="0">
+            <a:pPr rtl="1" algn="r" indent="0" marL="0">
               <a:buNone/>
             </a:pPr>
             <a:r>
@@ -3236,7 +3236,7 @@
           <a:bodyPr wrap="square" lIns="0" tIns="0" rIns="0" bIns="0" rtlCol="0" anchor="ctr"/>
           <a:lstStyle/>
           <a:p>
-            <a:pPr algn="r" indent="0" marL="0">
+            <a:pPr rtl="1" algn="r" indent="0" marL="0">
               <a:spcAft>
                 <a:spcPts val="1000"/>
               </a:spcAft>
@@ -3256,7 +3256,7 @@
             <a:endParaRPr lang="en-US" sz="1900" dirty="0"/>
           </a:p>
           <a:p>
-            <a:pPr algn="r" indent="0" marL="0">
+            <a:pPr rtl="1" algn="r" indent="0" marL="0">
               <a:spcAft>
                 <a:spcPts val="1000"/>
               </a:spcAft>
@@ -3276,7 +3276,7 @@
             <a:endParaRPr lang="en-US" sz="1900" dirty="0"/>
           </a:p>
           <a:p>
-            <a:pPr algn="r" indent="0" marL="0">
+            <a:pPr rtl="1" algn="r" indent="0" marL="0">
               <a:spcAft>
                 <a:spcPts val="1000"/>
               </a:spcAft>
@@ -3293,7 +3293,7 @@
               </a:rPr>
               <a:t>• זה קורה </a:t>
             </a:r>
-            <a:pPr algn="r" indent="0" marL="0">
+            <a:pPr rtl="1" algn="r" indent="0" marL="0">
               <a:spcAft>
                 <a:spcPts val="1000"/>
               </a:spcAft>
@@ -3310,7 +3310,7 @@
               </a:rPr>
               <a:t>בביטחון מלא</a:t>
             </a:r>
-            <a:pPr algn="r" indent="0" marL="0">
+            <a:pPr rtl="1" algn="r" indent="0" marL="0">
               <a:spcAft>
                 <a:spcPts val="1000"/>
               </a:spcAft>
@@ -3375,7 +3375,7 @@
           <a:bodyPr wrap="square" lIns="0" tIns="0" rIns="0" bIns="0" rtlCol="0" anchor="ctr"/>
           <a:lstStyle/>
           <a:p>
-            <a:pPr algn="r" indent="0" marL="0">
+            <a:pPr rtl="1" algn="r" indent="0" marL="0">
               <a:buNone/>
             </a:pPr>
             <a:r>
@@ -3588,7 +3588,7 @@
           <a:bodyPr wrap="square" lIns="0" tIns="0" rIns="0" bIns="0" rtlCol="0" anchor="ctr"/>
           <a:lstStyle/>
           <a:p>
-            <a:pPr algn="r" indent="0" marL="0">
+            <a:pPr rtl="1" algn="r" indent="0" marL="0">
               <a:spcAft>
                 <a:spcPts val="1000"/>
               </a:spcAft>
@@ -3605,7 +3605,7 @@
               </a:rPr>
               <a:t>• 84%</a:t>
             </a:r>
-            <a:pPr algn="r" indent="0" marL="0">
+            <a:pPr rtl="1" algn="r" indent="0" marL="0">
               <a:spcAft>
                 <a:spcPts val="1000"/>
               </a:spcAft>
@@ -3625,7 +3625,7 @@
             <a:endParaRPr lang="en-US" sz="1900" dirty="0"/>
           </a:p>
           <a:p>
-            <a:pPr algn="r" indent="0" marL="0">
+            <a:pPr rtl="1" algn="r" indent="0" marL="0">
               <a:spcAft>
                 <a:spcPts val="1000"/>
               </a:spcAft>
@@ -3642,7 +3642,7 @@
               </a:rPr>
               <a:t>• אבל רק </a:t>
             </a:r>
-            <a:pPr algn="r" indent="0" marL="0">
+            <a:pPr rtl="1" algn="r" indent="0" marL="0">
               <a:spcAft>
                 <a:spcPts val="1000"/>
               </a:spcAft>
@@ -3659,7 +3659,7 @@
               </a:rPr>
               <a:t>29%</a:t>
             </a:r>
-            <a:pPr algn="r" indent="0" marL="0">
+            <a:pPr rtl="1" algn="r" indent="0" marL="0">
               <a:spcAft>
                 <a:spcPts val="1000"/>
               </a:spcAft>
@@ -3679,7 +3679,7 @@
             <a:endParaRPr lang="en-US" sz="1900" dirty="0"/>
           </a:p>
           <a:p>
-            <a:pPr algn="r" indent="0" marL="0">
+            <a:pPr rtl="1" algn="r" indent="0" marL="0">
               <a:spcAft>
                 <a:spcPts val="1000"/>
               </a:spcAft>
@@ -3696,7 +3696,7 @@
               </a:rPr>
               <a:t>• 61%</a:t>
             </a:r>
-            <a:pPr algn="r" indent="0" marL="0">
+            <a:pPr rtl="1" algn="r" indent="0" marL="0">
               <a:spcAft>
                 <a:spcPts val="1000"/>
               </a:spcAft>
@@ -3716,7 +3716,7 @@
             <a:endParaRPr lang="en-US" sz="1900" dirty="0"/>
           </a:p>
           <a:p>
-            <a:pPr algn="r" indent="0" marL="0">
+            <a:pPr rtl="1" algn="r" indent="0" marL="0">
               <a:spcAft>
                 <a:spcPts val="1000"/>
               </a:spcAft>
@@ -3733,7 +3733,7 @@
               </a:rPr>
               <a:t>• קוד AI-heavy: </a:t>
             </a:r>
-            <a:pPr algn="r" indent="0" marL="0">
+            <a:pPr rtl="1" algn="r" indent="0" marL="0">
               <a:spcAft>
                 <a:spcPts val="1000"/>
               </a:spcAft>
@@ -3750,7 +3750,7 @@
               </a:rPr>
               <a:t>41%+</a:t>
             </a:r>
-            <a:pPr algn="r" indent="0" marL="0">
+            <a:pPr rtl="1" algn="r" indent="0" marL="0">
               <a:spcAft>
                 <a:spcPts val="1000"/>
               </a:spcAft>
@@ -3767,7 +3767,7 @@
               </a:rPr>
               <a:t> באגים, </a:t>
             </a:r>
-            <a:pPr algn="r" indent="0" marL="0">
+            <a:pPr rtl="1" algn="r" indent="0" marL="0">
               <a:spcAft>
                 <a:spcPts val="1000"/>
               </a:spcAft>
@@ -3784,7 +3784,7 @@
               </a:rPr>
               <a:t>7.2%-</a:t>
             </a:r>
-            <a:pPr algn="r" indent="0" marL="0">
+            <a:pPr rtl="1" algn="r" indent="0" marL="0">
               <a:spcAft>
                 <a:spcPts val="1000"/>
               </a:spcAft>
@@ -3849,7 +3849,7 @@
           <a:bodyPr wrap="square" lIns="0" tIns="0" rIns="0" bIns="0" rtlCol="0" anchor="ctr"/>
           <a:lstStyle/>
           <a:p>
-            <a:pPr algn="r" indent="0" marL="0">
+            <a:pPr rtl="1" algn="r" indent="0" marL="0">
               <a:buNone/>
             </a:pPr>
             <a:r>
@@ -4037,7 +4037,7 @@
           <a:bodyPr wrap="square" lIns="0" tIns="0" rIns="0" bIns="0" rtlCol="0" anchor="ctr"/>
           <a:lstStyle/>
           <a:p>
-            <a:pPr algn="r" indent="0" marL="0">
+            <a:pPr rtl="1" algn="r" indent="0" marL="0">
               <a:buNone/>
             </a:pPr>
             <a:r>
@@ -4076,7 +4076,7 @@
           <a:bodyPr wrap="square" lIns="0" tIns="0" rIns="0" bIns="0" rtlCol="0" anchor="ctr"/>
           <a:lstStyle/>
           <a:p>
-            <a:pPr algn="r" indent="0" marL="0">
+            <a:pPr rtl="1" algn="r" indent="0" marL="0">
               <a:spcAft>
                 <a:spcPts val="1000"/>
               </a:spcAft>
@@ -4096,7 +4096,7 @@
             <a:endParaRPr lang="en-US" sz="1900" dirty="0"/>
           </a:p>
           <a:p>
-            <a:pPr algn="r" indent="0" marL="0">
+            <a:pPr rtl="1" algn="r" indent="0" marL="0">
               <a:spcAft>
                 <a:spcPts val="1000"/>
               </a:spcAft>
@@ -4113,7 +4113,7 @@
               </a:rPr>
               <a:t>• בפועל: </a:t>
             </a:r>
-            <a:pPr algn="r" indent="0" marL="0">
+            <a:pPr rtl="1" algn="r" indent="0" marL="0">
               <a:spcAft>
                 <a:spcPts val="1000"/>
               </a:spcAft>
@@ -4133,7 +4133,7 @@
             <a:endParaRPr lang="en-US" sz="1900" dirty="0"/>
           </a:p>
           <a:p>
-            <a:pPr algn="r" indent="0" marL="0">
+            <a:pPr rtl="1" algn="r" indent="0" marL="0">
               <a:spcAft>
                 <a:spcPts val="1000"/>
               </a:spcAft>
@@ -4150,7 +4150,7 @@
               </a:rPr>
               <a:t>• אבל האמינו: </a:t>
             </a:r>
-            <a:pPr algn="r" indent="0" marL="0">
+            <a:pPr rtl="1" algn="r" indent="0" marL="0">
               <a:spcAft>
                 <a:spcPts val="1000"/>
               </a:spcAft>
@@ -4215,7 +4215,7 @@
           <a:bodyPr wrap="square" lIns="0" tIns="0" rIns="0" bIns="0" rtlCol="0" anchor="ctr"/>
           <a:lstStyle/>
           <a:p>
-            <a:pPr algn="r" indent="0" marL="0">
+            <a:pPr rtl="1" algn="r" indent="0" marL="0">
               <a:buNone/>
             </a:pPr>
             <a:r>
@@ -4403,7 +4403,7 @@
           <a:bodyPr wrap="square" lIns="0" tIns="0" rIns="0" bIns="0" rtlCol="0" anchor="ctr"/>
           <a:lstStyle/>
           <a:p>
-            <a:pPr algn="r" indent="0" marL="0">
+            <a:pPr rtl="1" algn="r" indent="0" marL="0">
               <a:buNone/>
             </a:pPr>
             <a:r>
@@ -4442,7 +4442,7 @@
           <a:bodyPr wrap="square" lIns="0" tIns="0" rIns="0" bIns="0" rtlCol="0" anchor="ctr"/>
           <a:lstStyle/>
           <a:p>
-            <a:pPr algn="r" indent="0" marL="0">
+            <a:pPr rtl="1" algn="r" indent="0" marL="0">
               <a:spcAft>
                 <a:spcPts val="1000"/>
               </a:spcAft>
@@ -4459,7 +4459,7 @@
               </a:rPr>
               <a:t>• 1. הבנת הבעיה</a:t>
             </a:r>
-            <a:pPr algn="r" indent="0" marL="0">
+            <a:pPr rtl="1" algn="r" indent="0" marL="0">
               <a:spcAft>
                 <a:spcPts val="1000"/>
               </a:spcAft>
@@ -4479,7 +4479,7 @@
             <a:endParaRPr lang="en-US" sz="1900" dirty="0"/>
           </a:p>
           <a:p>
-            <a:pPr algn="r" indent="0" marL="0">
+            <a:pPr rtl="1" algn="r" indent="0" marL="0">
               <a:spcAft>
                 <a:spcPts val="1000"/>
               </a:spcAft>
@@ -4496,7 +4496,7 @@
               </a:rPr>
               <a:t>• 2. Specification</a:t>
             </a:r>
-            <a:pPr algn="r" indent="0" marL="0">
+            <a:pPr rtl="1" algn="r" indent="0" marL="0">
               <a:spcAft>
                 <a:spcPts val="1000"/>
               </a:spcAft>
@@ -4516,7 +4516,7 @@
             <a:endParaRPr lang="en-US" sz="1900" dirty="0"/>
           </a:p>
           <a:p>
-            <a:pPr algn="r" indent="0" marL="0">
+            <a:pPr rtl="1" algn="r" indent="0" marL="0">
               <a:spcAft>
                 <a:spcPts val="1000"/>
               </a:spcAft>
@@ -4533,7 +4533,7 @@
               </a:rPr>
               <a:t>• 3. בניית Context</a:t>
             </a:r>
-            <a:pPr algn="r" indent="0" marL="0">
+            <a:pPr rtl="1" algn="r" indent="0" marL="0">
               <a:spcAft>
                 <a:spcPts val="1000"/>
               </a:spcAft>
@@ -4553,7 +4553,7 @@
             <a:endParaRPr lang="en-US" sz="1900" dirty="0"/>
           </a:p>
           <a:p>
-            <a:pPr algn="r" indent="0" marL="0">
+            <a:pPr rtl="1" algn="r" indent="0" marL="0">
               <a:spcAft>
                 <a:spcPts val="1000"/>
               </a:spcAft>
@@ -4570,7 +4570,7 @@
               </a:rPr>
               <a:t>• 4. תכנון עם AI</a:t>
             </a:r>
-            <a:pPr algn="r" indent="0" marL="0">
+            <a:pPr rtl="1" algn="r" indent="0" marL="0">
               <a:spcAft>
                 <a:spcPts val="1000"/>
               </a:spcAft>
@@ -4590,7 +4590,7 @@
             <a:endParaRPr lang="en-US" sz="1900" dirty="0"/>
           </a:p>
           <a:p>
-            <a:pPr algn="r" indent="0" marL="0">
+            <a:pPr rtl="1" algn="r" indent="0" marL="0">
               <a:spcAft>
                 <a:spcPts val="1000"/>
               </a:spcAft>
@@ -4607,7 +4607,7 @@
               </a:rPr>
               <a:t>• 5. מימוש עם AI</a:t>
             </a:r>
-            <a:pPr algn="r" indent="0" marL="0">
+            <a:pPr rtl="1" algn="r" indent="0" marL="0">
               <a:spcAft>
                 <a:spcPts val="1000"/>
               </a:spcAft>
@@ -4672,7 +4672,7 @@
           <a:bodyPr wrap="square" lIns="0" tIns="0" rIns="0" bIns="0" rtlCol="0" anchor="ctr"/>
           <a:lstStyle/>
           <a:p>
-            <a:pPr algn="r" indent="0" marL="0">
+            <a:pPr rtl="1" algn="r" indent="0" marL="0">
               <a:buNone/>
             </a:pPr>
             <a:r>
@@ -4821,7 +4821,7 @@
           <a:bodyPr wrap="square" lIns="0" tIns="0" rIns="0" bIns="0" rtlCol="0" anchor="ctr"/>
           <a:lstStyle/>
           <a:p>
-            <a:pPr algn="r" indent="0" marL="0">
+            <a:pPr rtl="1" algn="r" indent="0" marL="0">
               <a:spcAft>
                 <a:spcPts val="1000"/>
               </a:spcAft>
@@ -4838,7 +4838,7 @@
               </a:rPr>
               <a:t>• 6. Code Review</a:t>
             </a:r>
-            <a:pPr algn="r" indent="0" marL="0">
+            <a:pPr rtl="1" algn="r" indent="0" marL="0">
               <a:spcAft>
                 <a:spcPts val="1000"/>
               </a:spcAft>
@@ -4858,7 +4858,7 @@
             <a:endParaRPr lang="en-US" sz="1900" dirty="0"/>
           </a:p>
           <a:p>
-            <a:pPr algn="r" indent="0" marL="0">
+            <a:pPr rtl="1" algn="r" indent="0" marL="0">
               <a:spcAft>
                 <a:spcPts val="1000"/>
               </a:spcAft>
@@ -4875,7 +4875,7 @@
               </a:rPr>
               <a:t>• 7. Testing</a:t>
             </a:r>
-            <a:pPr algn="r" indent="0" marL="0">
+            <a:pPr rtl="1" algn="r" indent="0" marL="0">
               <a:spcAft>
                 <a:spcPts val="1000"/>
               </a:spcAft>
@@ -4895,7 +4895,7 @@
             <a:endParaRPr lang="en-US" sz="1900" dirty="0"/>
           </a:p>
           <a:p>
-            <a:pPr algn="r" indent="0" marL="0">
+            <a:pPr rtl="1" algn="r" indent="0" marL="0">
               <a:spcAft>
                 <a:spcPts val="1000"/>
               </a:spcAft>
@@ -4912,7 +4912,7 @@
               </a:rPr>
               <a:t>• 8. Commit</a:t>
             </a:r>
-            <a:pPr algn="r" indent="0" marL="0">
+            <a:pPr rtl="1" algn="r" indent="0" marL="0">
               <a:spcAft>
                 <a:spcPts val="1000"/>
               </a:spcAft>
@@ -4932,7 +4932,7 @@
             <a:endParaRPr lang="en-US" sz="1900" dirty="0"/>
           </a:p>
           <a:p>
-            <a:pPr algn="r" indent="0" marL="0">
+            <a:pPr rtl="1" algn="r" indent="0" marL="0">
               <a:spcAft>
                 <a:spcPts val="1000"/>
               </a:spcAft>
@@ -4949,7 +4949,7 @@
               </a:rPr>
               <a:t>• 9. Deploy</a:t>
             </a:r>
-            <a:pPr algn="r" indent="0" marL="0">
+            <a:pPr rtl="1" algn="r" indent="0" marL="0">
               <a:spcAft>
                 <a:spcPts val="1000"/>
               </a:spcAft>
@@ -4969,7 +4969,7 @@
             <a:endParaRPr lang="en-US" sz="1900" dirty="0"/>
           </a:p>
           <a:p>
-            <a:pPr algn="r" indent="0" marL="0">
+            <a:pPr rtl="1" algn="r" indent="0" marL="0">
               <a:spcAft>
                 <a:spcPts val="1000"/>
               </a:spcAft>
@@ -4986,7 +4986,7 @@
               </a:rPr>
               <a:t>• 10. שיתוף</a:t>
             </a:r>
-            <a:pPr algn="r" indent="0" marL="0">
+            <a:pPr rtl="1" algn="r" indent="0" marL="0">
               <a:spcAft>
                 <a:spcPts val="1000"/>
               </a:spcAft>
@@ -5051,7 +5051,7 @@
           <a:bodyPr wrap="square" lIns="0" tIns="0" rIns="0" bIns="0" rtlCol="0" anchor="ctr"/>
           <a:lstStyle/>
           <a:p>
-            <a:pPr algn="r" indent="0" marL="0">
+            <a:pPr rtl="1" algn="r" indent="0" marL="0">
               <a:buNone/>
             </a:pPr>
             <a:r>
@@ -5200,7 +5200,7 @@
           <a:bodyPr wrap="square" lIns="0" tIns="0" rIns="0" bIns="0" rtlCol="0" anchor="ctr"/>
           <a:lstStyle/>
           <a:p>
-            <a:pPr algn="r" indent="0" marL="0">
+            <a:pPr rtl="1" algn="r" indent="0" marL="0">
               <a:spcAft>
                 <a:spcPts val="1000"/>
               </a:spcAft>
@@ -5220,7 +5220,7 @@
             <a:endParaRPr lang="en-US" sz="1900" dirty="0"/>
           </a:p>
           <a:p>
-            <a:pPr algn="r" indent="0" marL="0">
+            <a:pPr rtl="1" algn="r" indent="0" marL="0">
               <a:spcAft>
                 <a:spcPts val="1000"/>
               </a:spcAft>
@@ -5237,7 +5237,7 @@
               </a:rPr>
               <a:t>• קוד קיים (Brownfield) בלי תהליך מסודר: </a:t>
             </a:r>
-            <a:pPr algn="r" indent="0" marL="0">
+            <a:pPr rtl="1" algn="r" indent="0" marL="0">
               <a:spcAft>
                 <a:spcPts val="1000"/>
               </a:spcAft>
@@ -5254,7 +5254,7 @@
               </a:rPr>
               <a:t>~10%</a:t>
             </a:r>
-            <a:pPr algn="r" indent="0" marL="0">
+            <a:pPr rtl="1" algn="r" indent="0" marL="0">
               <a:spcAft>
                 <a:spcPts val="1000"/>
               </a:spcAft>
@@ -5274,7 +5274,7 @@
             <a:endParaRPr lang="en-US" sz="1900" dirty="0"/>
           </a:p>
           <a:p>
-            <a:pPr algn="r" indent="0" marL="0">
+            <a:pPr rtl="1" algn="r" indent="0" marL="0">
               <a:spcAft>
                 <a:spcPts val="1000"/>
               </a:spcAft>
@@ -5291,7 +5291,7 @@
               </a:rPr>
               <a:t>• אותם כלים, על פרויקט חדש שנבנה מאפס (Greenfield) עם Workflow ברור: </a:t>
             </a:r>
-            <a:pPr algn="r" indent="0" marL="0">
+            <a:pPr rtl="1" algn="r" indent="0" marL="0">
               <a:spcAft>
                 <a:spcPts val="1000"/>
               </a:spcAft>
@@ -5308,7 +5308,7 @@
               </a:rPr>
               <a:t>35-40%</a:t>
             </a:r>
-            <a:pPr algn="r" indent="0" marL="0">
+            <a:pPr rtl="1" algn="r" indent="0" marL="0">
               <a:spcAft>
                 <a:spcPts val="1000"/>
               </a:spcAft>
@@ -5328,7 +5328,7 @@
             <a:endParaRPr lang="en-US" sz="1900" dirty="0"/>
           </a:p>
           <a:p>
-            <a:pPr algn="r" indent="0" marL="0">
+            <a:pPr rtl="1" algn="r" indent="0" marL="0">
               <a:spcAft>
                 <a:spcPts val="1000"/>
               </a:spcAft>
@@ -5345,7 +5345,7 @@
               </a:rPr>
               <a:t>• בלי תהליך מסודר: </a:t>
             </a:r>
-            <a:pPr algn="r" indent="0" marL="0">
+            <a:pPr rtl="1" algn="r" indent="0" marL="0">
               <a:spcAft>
                 <a:spcPts val="1000"/>
               </a:spcAft>
@@ -5362,7 +5362,7 @@
               </a:rPr>
               <a:t>30-41%</a:t>
             </a:r>
-            <a:pPr algn="r" indent="0" marL="0">
+            <a:pPr rtl="1" algn="r" indent="0" marL="0">
               <a:spcAft>
                 <a:spcPts val="1000"/>
               </a:spcAft>
@@ -5379,7 +5379,7 @@
               </a:rPr>
               <a:t> יותר חוב טכני, PR עם AI = </a:t>
             </a:r>
-            <a:pPr algn="r" indent="0" marL="0">
+            <a:pPr rtl="1" algn="r" indent="0" marL="0">
               <a:spcAft>
                 <a:spcPts val="1000"/>
               </a:spcAft>
@@ -5396,7 +5396,7 @@
               </a:rPr>
               <a:t>פי 1.7</a:t>
             </a:r>
-            <a:pPr algn="r" indent="0" marL="0">
+            <a:pPr rtl="1" algn="r" indent="0" marL="0">
               <a:spcAft>
                 <a:spcPts val="1000"/>
               </a:spcAft>
@@ -5461,7 +5461,7 @@
           <a:bodyPr wrap="square" lIns="0" tIns="0" rIns="0" bIns="0" rtlCol="0" anchor="ctr"/>
           <a:lstStyle/>
           <a:p>
-            <a:pPr algn="r" indent="0" marL="0">
+            <a:pPr rtl="1" algn="r" indent="0" marL="0">
               <a:buNone/>
             </a:pPr>
             <a:r>
@@ -5649,7 +5649,7 @@
           <a:bodyPr wrap="square" lIns="0" tIns="0" rIns="0" bIns="0" rtlCol="0" anchor="ctr"/>
           <a:lstStyle/>
           <a:p>
-            <a:pPr algn="r" indent="0" marL="0">
+            <a:pPr rtl="1" algn="r" indent="0" marL="0">
               <a:buNone/>
             </a:pPr>
             <a:r>
@@ -5688,7 +5688,7 @@
           <a:bodyPr wrap="square" lIns="0" tIns="0" rIns="0" bIns="0" rtlCol="0" anchor="ctr"/>
           <a:lstStyle/>
           <a:p>
-            <a:pPr algn="r" indent="0" marL="0">
+            <a:pPr rtl="1" algn="r" indent="0" marL="0">
               <a:spcAft>
                 <a:spcPts val="1000"/>
               </a:spcAft>
@@ -5708,7 +5708,7 @@
             <a:endParaRPr lang="en-US" sz="1900" dirty="0"/>
           </a:p>
           <a:p>
-            <a:pPr algn="r" indent="0" marL="0">
+            <a:pPr rtl="1" algn="r" indent="0" marL="0">
               <a:spcAft>
                 <a:spcPts val="1000"/>
               </a:spcAft>
@@ -5728,7 +5728,7 @@
             <a:endParaRPr lang="en-US" sz="1900" dirty="0"/>
           </a:p>
           <a:p>
-            <a:pPr algn="r" indent="0" marL="0">
+            <a:pPr rtl="1" algn="r" indent="0" marL="0">
               <a:spcAft>
                 <a:spcPts val="1000"/>
               </a:spcAft>
@@ -5748,7 +5748,7 @@
             <a:endParaRPr lang="en-US" sz="1900" dirty="0"/>
           </a:p>
           <a:p>
-            <a:pPr algn="r" indent="0" marL="0">
+            <a:pPr rtl="1" algn="r" indent="0" marL="0">
               <a:spcAft>
                 <a:spcPts val="1000"/>
               </a:spcAft>
@@ -5813,7 +5813,7 @@
           <a:bodyPr wrap="square" lIns="0" tIns="0" rIns="0" bIns="0" rtlCol="0" anchor="ctr"/>
           <a:lstStyle/>
           <a:p>
-            <a:pPr algn="r" indent="0" marL="0">
+            <a:pPr rtl="1" algn="r" indent="0" marL="0">
               <a:buNone/>
             </a:pPr>
             <a:r>
@@ -6026,7 +6026,7 @@
           <a:bodyPr wrap="square" lIns="0" tIns="0" rIns="0" bIns="0" rtlCol="0" anchor="ctr"/>
           <a:lstStyle/>
           <a:p>
-            <a:pPr algn="r" indent="0" marL="0">
+            <a:pPr rtl="1" algn="r" indent="0" marL="0">
               <a:buNone/>
             </a:pPr>
             <a:r>
@@ -6065,7 +6065,7 @@
           <a:bodyPr wrap="square" lIns="0" tIns="0" rIns="0" bIns="0" rtlCol="0" anchor="ctr"/>
           <a:lstStyle/>
           <a:p>
-            <a:pPr algn="r" indent="0" marL="0">
+            <a:pPr rtl="1" algn="r" indent="0" marL="0">
               <a:spcAft>
                 <a:spcPts val="1000"/>
               </a:spcAft>
@@ -6085,7 +6085,7 @@
             <a:endParaRPr lang="en-US" sz="1900" dirty="0"/>
           </a:p>
           <a:p>
-            <a:pPr algn="r" indent="0" marL="0">
+            <a:pPr rtl="1" algn="r" indent="0" marL="0">
               <a:spcAft>
                 <a:spcPts val="1000"/>
               </a:spcAft>
@@ -6105,7 +6105,7 @@
             <a:endParaRPr lang="en-US" sz="1900" dirty="0"/>
           </a:p>
           <a:p>
-            <a:pPr algn="r" indent="0" marL="0">
+            <a:pPr rtl="1" algn="r" indent="0" marL="0">
               <a:spcAft>
                 <a:spcPts val="1000"/>
               </a:spcAft>
@@ -6125,7 +6125,7 @@
             <a:endParaRPr lang="en-US" sz="1900" dirty="0"/>
           </a:p>
           <a:p>
-            <a:pPr algn="r" indent="0" marL="0">
+            <a:pPr rtl="1" algn="r" indent="0" marL="0">
               <a:spcAft>
                 <a:spcPts val="1000"/>
               </a:spcAft>
@@ -6142,7 +6142,7 @@
               </a:rPr>
               <a:t>• פעילות זוגות:</a:t>
             </a:r>
-            <a:pPr algn="r" indent="0" marL="0">
+            <a:pPr rtl="1" algn="r" indent="0" marL="0">
               <a:spcAft>
                 <a:spcPts val="1000"/>
               </a:spcAft>
@@ -6207,7 +6207,7 @@
           <a:bodyPr wrap="square" lIns="0" tIns="0" rIns="0" bIns="0" rtlCol="0" anchor="ctr"/>
           <a:lstStyle/>
           <a:p>
-            <a:pPr algn="r" indent="0" marL="0">
+            <a:pPr rtl="1" algn="r" indent="0" marL="0">
               <a:buNone/>
             </a:pPr>
             <a:r>
@@ -6356,7 +6356,7 @@
           <a:bodyPr wrap="square" lIns="0" tIns="0" rIns="0" bIns="0" rtlCol="0" anchor="ctr"/>
           <a:lstStyle/>
           <a:p>
-            <a:pPr algn="r" indent="0" marL="0">
+            <a:pPr rtl="1" algn="r" indent="0" marL="0">
               <a:buNone/>
             </a:pPr>
             <a:r>
@@ -6395,7 +6395,7 @@
           <a:bodyPr wrap="square" lIns="0" tIns="0" rIns="0" bIns="0" rtlCol="0" anchor="ctr"/>
           <a:lstStyle/>
           <a:p>
-            <a:pPr algn="r" indent="0" marL="0">
+            <a:pPr rtl="1" algn="r" indent="0" marL="0">
               <a:spcAft>
                 <a:spcPts val="1000"/>
               </a:spcAft>
@@ -6412,7 +6412,7 @@
               </a:rPr>
               <a:t>• Stripe:</a:t>
             </a:r>
-            <a:pPr algn="r" indent="0" marL="0">
+            <a:pPr rtl="1" algn="r" indent="0" marL="0">
               <a:spcAft>
                 <a:spcPts val="1000"/>
               </a:spcAft>
@@ -6432,7 +6432,7 @@
             <a:endParaRPr lang="en-US" sz="1900" dirty="0"/>
           </a:p>
           <a:p>
-            <a:pPr algn="r" indent="0" marL="0">
+            <a:pPr rtl="1" algn="r" indent="0" marL="0">
               <a:spcAft>
                 <a:spcPts val="1000"/>
               </a:spcAft>
@@ -6449,7 +6449,7 @@
               </a:rPr>
               <a:t>• TELUS:</a:t>
             </a:r>
-            <a:pPr algn="r" indent="0" marL="0">
+            <a:pPr rtl="1" algn="r" indent="0" marL="0">
               <a:spcAft>
                 <a:spcPts val="1000"/>
               </a:spcAft>
@@ -6469,7 +6469,7 @@
             <a:endParaRPr lang="en-US" sz="1900" dirty="0"/>
           </a:p>
           <a:p>
-            <a:pPr algn="r" indent="0" marL="0">
+            <a:pPr rtl="1" algn="r" indent="0" marL="0">
               <a:spcAft>
                 <a:spcPts val="1000"/>
               </a:spcAft>
@@ -6486,7 +6486,7 @@
               </a:rPr>
               <a:t>• Zapier:</a:t>
             </a:r>
-            <a:pPr algn="r" indent="0" marL="0">
+            <a:pPr rtl="1" algn="r" indent="0" marL="0">
               <a:spcAft>
                 <a:spcPts val="1000"/>
               </a:spcAft>
@@ -6551,7 +6551,7 @@
           <a:bodyPr wrap="square" lIns="0" tIns="0" rIns="0" bIns="0" rtlCol="0" anchor="ctr"/>
           <a:lstStyle/>
           <a:p>
-            <a:pPr algn="r" indent="0" marL="0">
+            <a:pPr rtl="1" algn="r" indent="0" marL="0">
               <a:buNone/>
             </a:pPr>
             <a:r>
@@ -6700,7 +6700,7 @@
           <a:bodyPr wrap="square" lIns="0" tIns="0" rIns="0" bIns="0" rtlCol="0" anchor="ctr"/>
           <a:lstStyle/>
           <a:p>
-            <a:pPr algn="ctr" indent="0" marL="0">
+            <a:pPr rtl="1" algn="ctr" indent="0" marL="0">
               <a:buNone/>
             </a:pPr>
             <a:r>
@@ -7014,7 +7014,7 @@
           <a:bodyPr wrap="square" lIns="0" tIns="0" rIns="0" bIns="0" rtlCol="0" anchor="ctr"/>
           <a:lstStyle/>
           <a:p>
-            <a:pPr algn="r" indent="0" marL="0">
+            <a:pPr rtl="1" algn="r" indent="0" marL="0">
               <a:buNone/>
             </a:pPr>
             <a:r>
@@ -7053,7 +7053,7 @@
           <a:bodyPr wrap="square" lIns="0" tIns="0" rIns="0" bIns="0" rtlCol="0" anchor="ctr"/>
           <a:lstStyle/>
           <a:p>
-            <a:pPr algn="r" indent="0" marL="0">
+            <a:pPr rtl="1" algn="r" indent="0" marL="0">
               <a:spcAft>
                 <a:spcPts val="1000"/>
               </a:spcAft>
@@ -7070,7 +7070,7 @@
               </a:rPr>
               <a:t>• LLM (Large Language Model)</a:t>
             </a:r>
-            <a:pPr algn="r" indent="0" marL="0">
+            <a:pPr rtl="1" algn="r" indent="0" marL="0">
               <a:spcAft>
                 <a:spcPts val="1000"/>
               </a:spcAft>
@@ -7090,7 +7090,7 @@
             <a:endParaRPr lang="en-US" sz="1900" dirty="0"/>
           </a:p>
           <a:p>
-            <a:pPr algn="r" indent="0" marL="0">
+            <a:pPr rtl="1" algn="r" indent="0" marL="0">
               <a:spcAft>
                 <a:spcPts val="1000"/>
               </a:spcAft>
@@ -7110,7 +7110,7 @@
             <a:endParaRPr lang="en-US" sz="1900" dirty="0"/>
           </a:p>
           <a:p>
-            <a:pPr algn="r" indent="0" marL="0">
+            <a:pPr rtl="1" algn="r" indent="0" marL="0">
               <a:spcAft>
                 <a:spcPts val="1000"/>
               </a:spcAft>
@@ -7175,7 +7175,7 @@
           <a:bodyPr wrap="square" lIns="0" tIns="0" rIns="0" bIns="0" rtlCol="0" anchor="ctr"/>
           <a:lstStyle/>
           <a:p>
-            <a:pPr algn="r" indent="0" marL="0">
+            <a:pPr rtl="1" algn="r" indent="0" marL="0">
               <a:buNone/>
             </a:pPr>
             <a:r>
@@ -7349,7 +7349,7 @@
           <a:bodyPr wrap="square" lIns="0" tIns="0" rIns="0" bIns="0" rtlCol="0" anchor="ctr"/>
           <a:lstStyle/>
           <a:p>
-            <a:pPr algn="ctr" indent="0" marL="0">
+            <a:pPr rtl="1" algn="ctr" indent="0" marL="0">
               <a:buNone/>
             </a:pPr>
             <a:r>
@@ -7450,7 +7450,7 @@
           <a:bodyPr wrap="square" lIns="0" tIns="0" rIns="0" bIns="0" rtlCol="0" anchor="ctr"/>
           <a:lstStyle/>
           <a:p>
-            <a:pPr algn="r" indent="0" marL="0">
+            <a:pPr rtl="1" algn="r" indent="0" marL="0">
               <a:spcAft>
                 <a:spcPts val="800"/>
               </a:spcAft>
@@ -7470,7 +7470,7 @@
             <a:endParaRPr lang="en-US" sz="1800" dirty="0"/>
           </a:p>
           <a:p>
-            <a:pPr algn="r" indent="0" marL="0">
+            <a:pPr rtl="1" algn="r" indent="0" marL="0">
               <a:spcAft>
                 <a:spcPts val="800"/>
               </a:spcAft>
@@ -7490,7 +7490,7 @@
             <a:endParaRPr lang="en-US" sz="1800" dirty="0"/>
           </a:p>
           <a:p>
-            <a:pPr algn="r" indent="0" marL="0">
+            <a:pPr rtl="1" algn="r" indent="0" marL="0">
               <a:spcAft>
                 <a:spcPts val="800"/>
               </a:spcAft>
@@ -7510,7 +7510,7 @@
             <a:endParaRPr lang="en-US" sz="1800" dirty="0"/>
           </a:p>
           <a:p>
-            <a:pPr algn="r" indent="0" marL="0">
+            <a:pPr rtl="1" algn="r" indent="0" marL="0">
               <a:spcAft>
                 <a:spcPts val="800"/>
               </a:spcAft>
@@ -7726,7 +7726,7 @@
           <a:bodyPr wrap="square" lIns="0" tIns="0" rIns="0" bIns="0" rtlCol="0" anchor="ctr"/>
           <a:lstStyle/>
           <a:p>
-            <a:pPr algn="r" indent="0" marL="0">
+            <a:pPr rtl="1" algn="r" indent="0" marL="0">
               <a:spcAft>
                 <a:spcPts val="1600"/>
               </a:spcAft>
@@ -7746,7 +7746,7 @@
             <a:endParaRPr lang="en-US" sz="1800" dirty="0"/>
           </a:p>
           <a:p>
-            <a:pPr algn="r" indent="0" marL="0">
+            <a:pPr rtl="1" algn="r" indent="0" marL="0">
               <a:spcAft>
                 <a:spcPts val="1600"/>
               </a:spcAft>
@@ -7766,7 +7766,7 @@
             <a:endParaRPr lang="en-US" sz="1800" dirty="0"/>
           </a:p>
           <a:p>
-            <a:pPr algn="r" indent="0" marL="0">
+            <a:pPr rtl="1" algn="r" indent="0" marL="0">
               <a:spcAft>
                 <a:spcPts val="1600"/>
               </a:spcAft>
@@ -7980,7 +7980,7 @@
           <a:bodyPr wrap="square" lIns="0" tIns="0" rIns="0" bIns="0" rtlCol="0" anchor="ctr"/>
           <a:lstStyle/>
           <a:p>
-            <a:pPr algn="r" indent="0" marL="0">
+            <a:pPr rtl="1" algn="r" indent="0" marL="0">
               <a:spcAft>
                 <a:spcPts val="1200"/>
               </a:spcAft>
@@ -8000,7 +8000,7 @@
             <a:endParaRPr lang="en-US" sz="1500" dirty="0"/>
           </a:p>
           <a:p>
-            <a:pPr algn="r" indent="0" marL="0">
+            <a:pPr rtl="1" algn="r" indent="0" marL="0">
               <a:spcAft>
                 <a:spcPts val="1200"/>
               </a:spcAft>
@@ -8020,7 +8020,7 @@
             <a:endParaRPr lang="en-US" sz="1500" dirty="0"/>
           </a:p>
           <a:p>
-            <a:pPr algn="r" indent="0" marL="0">
+            <a:pPr rtl="1" algn="r" indent="0" marL="0">
               <a:spcAft>
                 <a:spcPts val="1200"/>
               </a:spcAft>
@@ -8040,7 +8040,7 @@
             <a:endParaRPr lang="en-US" sz="1500" dirty="0"/>
           </a:p>
           <a:p>
-            <a:pPr algn="r" indent="0" marL="0">
+            <a:pPr rtl="1" algn="r" indent="0" marL="0">
               <a:spcAft>
                 <a:spcPts val="1200"/>
               </a:spcAft>
@@ -8060,7 +8060,7 @@
             <a:endParaRPr lang="en-US" sz="1500" dirty="0"/>
           </a:p>
           <a:p>
-            <a:pPr algn="r" indent="0" marL="0">
+            <a:pPr rtl="1" algn="r" indent="0" marL="0">
               <a:spcAft>
                 <a:spcPts val="1200"/>
               </a:spcAft>
@@ -8080,7 +8080,7 @@
             <a:endParaRPr lang="en-US" sz="1500" dirty="0"/>
           </a:p>
           <a:p>
-            <a:pPr algn="r" indent="0" marL="0">
+            <a:pPr rtl="1" algn="r" indent="0" marL="0">
               <a:spcAft>
                 <a:spcPts val="1200"/>
               </a:spcAft>
@@ -8100,7 +8100,7 @@
             <a:endParaRPr lang="en-US" sz="1500" dirty="0"/>
           </a:p>
           <a:p>
-            <a:pPr algn="r" indent="0" marL="0">
+            <a:pPr rtl="1" algn="r" indent="0" marL="0">
               <a:spcAft>
                 <a:spcPts val="1200"/>
               </a:spcAft>
@@ -8291,7 +8291,7 @@
           <a:bodyPr wrap="square" lIns="0" tIns="0" rIns="0" bIns="0" rtlCol="0" anchor="ctr"/>
           <a:lstStyle/>
           <a:p>
-            <a:pPr algn="r" indent="0" marL="0">
+            <a:pPr rtl="1" algn="r" indent="0" marL="0">
               <a:buNone/>
             </a:pPr>
             <a:r>
@@ -8330,7 +8330,7 @@
           <a:bodyPr wrap="square" lIns="0" tIns="0" rIns="0" bIns="0" rtlCol="0" anchor="ctr"/>
           <a:lstStyle/>
           <a:p>
-            <a:pPr algn="r" indent="0" marL="0">
+            <a:pPr rtl="1" algn="r" indent="0" marL="0">
               <a:spcAft>
                 <a:spcPts val="1000"/>
               </a:spcAft>
@@ -8350,7 +8350,7 @@
             <a:endParaRPr lang="en-US" sz="1900" dirty="0"/>
           </a:p>
           <a:p>
-            <a:pPr algn="r" indent="0" marL="0">
+            <a:pPr rtl="1" algn="r" indent="0" marL="0">
               <a:spcAft>
                 <a:spcPts val="1000"/>
               </a:spcAft>
@@ -8370,7 +8370,7 @@
             <a:endParaRPr lang="en-US" sz="1900" dirty="0"/>
           </a:p>
           <a:p>
-            <a:pPr algn="r" indent="0" marL="0">
+            <a:pPr rtl="1" algn="r" indent="0" marL="0">
               <a:spcAft>
                 <a:spcPts val="1000"/>
               </a:spcAft>
@@ -8387,7 +8387,7 @@
               </a:rPr>
               <a:t>• לא</a:t>
             </a:r>
-            <a:pPr algn="r" indent="0" marL="0">
+            <a:pPr rtl="1" algn="r" indent="0" marL="0">
               <a:spcAft>
                 <a:spcPts val="1000"/>
               </a:spcAft>
@@ -8407,7 +8407,7 @@
             <a:endParaRPr lang="en-US" sz="1900" dirty="0"/>
           </a:p>
           <a:p>
-            <a:pPr algn="r" indent="0" marL="0">
+            <a:pPr rtl="1" algn="r" indent="0" marL="0">
               <a:spcAft>
                 <a:spcPts val="1000"/>
               </a:spcAft>
@@ -8424,7 +8424,7 @@
               </a:rPr>
               <a:t>• כן</a:t>
             </a:r>
-            <a:pPr algn="r" indent="0" marL="0">
+            <a:pPr rtl="1" algn="r" indent="0" marL="0">
               <a:spcAft>
                 <a:spcPts val="1000"/>
               </a:spcAft>
@@ -8489,7 +8489,7 @@
           <a:bodyPr wrap="square" lIns="0" tIns="0" rIns="0" bIns="0" rtlCol="0" anchor="ctr"/>
           <a:lstStyle/>
           <a:p>
-            <a:pPr algn="r" indent="0" marL="0">
+            <a:pPr rtl="1" algn="r" indent="0" marL="0">
               <a:buNone/>
             </a:pPr>
             <a:r>
@@ -8702,7 +8702,7 @@
           <a:bodyPr wrap="square" lIns="0" tIns="0" rIns="0" bIns="0" rtlCol="0" anchor="ctr"/>
           <a:lstStyle/>
           <a:p>
-            <a:pPr algn="r" indent="0" marL="0">
+            <a:pPr rtl="1" algn="r" indent="0" marL="0">
               <a:buNone/>
             </a:pPr>
             <a:r>
@@ -8741,7 +8741,7 @@
           <a:bodyPr wrap="square" lIns="0" tIns="0" rIns="0" bIns="0" rtlCol="0" anchor="ctr"/>
           <a:lstStyle/>
           <a:p>
-            <a:pPr algn="r" indent="0" marL="0">
+            <a:pPr rtl="1" algn="r" indent="0" marL="0">
               <a:spcAft>
                 <a:spcPts val="1000"/>
               </a:spcAft>
@@ -8758,7 +8758,7 @@
               </a:rPr>
               <a:t>• AI-Native (הגישה של הקורס):</a:t>
             </a:r>
-            <a:pPr algn="r" indent="0" marL="0">
+            <a:pPr rtl="1" algn="r" indent="0" marL="0">
               <a:spcAft>
                 <a:spcPts val="1000"/>
               </a:spcAft>
@@ -8778,7 +8778,7 @@
             <a:endParaRPr lang="en-US" sz="1900" dirty="0"/>
           </a:p>
           <a:p>
-            <a:pPr algn="r" indent="0" marL="0">
+            <a:pPr rtl="1" algn="r" indent="0" marL="0">
               <a:spcAft>
                 <a:spcPts val="1000"/>
               </a:spcAft>
@@ -8795,7 +8795,7 @@
               </a:rPr>
               <a:t>• הגישה הישנה:</a:t>
             </a:r>
-            <a:pPr algn="r" indent="0" marL="0">
+            <a:pPr rtl="1" algn="r" indent="0" marL="0">
               <a:spcAft>
                 <a:spcPts val="1000"/>
               </a:spcAft>
@@ -8815,7 +8815,7 @@
             <a:endParaRPr lang="en-US" sz="1900" dirty="0"/>
           </a:p>
           <a:p>
-            <a:pPr algn="r" indent="0" marL="0">
+            <a:pPr rtl="1" algn="r" indent="0" marL="0">
               <a:spcAft>
                 <a:spcPts val="1000"/>
               </a:spcAft>
@@ -8880,7 +8880,7 @@
           <a:bodyPr wrap="square" lIns="0" tIns="0" rIns="0" bIns="0" rtlCol="0" anchor="ctr"/>
           <a:lstStyle/>
           <a:p>
-            <a:pPr algn="r" indent="0" marL="0">
+            <a:pPr rtl="1" algn="r" indent="0" marL="0">
               <a:buNone/>
             </a:pPr>
             <a:r>
@@ -9029,7 +9029,7 @@
           <a:bodyPr wrap="square" lIns="0" tIns="0" rIns="0" bIns="0" rtlCol="0" anchor="ctr"/>
           <a:lstStyle/>
           <a:p>
-            <a:pPr algn="r" indent="0" marL="0">
+            <a:pPr rtl="1" algn="r" indent="0" marL="0">
               <a:spcAft>
                 <a:spcPts val="1000"/>
               </a:spcAft>
@@ -9046,7 +9046,7 @@
               </a:rPr>
               <a:t>• 92.6%</a:t>
             </a:r>
-            <a:pPr algn="r" indent="0" marL="0">
+            <a:pPr rtl="1" algn="r" indent="0" marL="0">
               <a:spcAft>
                 <a:spcPts val="1000"/>
               </a:spcAft>
@@ -9066,7 +9066,7 @@
             <a:endParaRPr lang="en-US" sz="1900" dirty="0"/>
           </a:p>
           <a:p>
-            <a:pPr algn="r" indent="0" marL="0">
+            <a:pPr rtl="1" algn="r" indent="0" marL="0">
               <a:spcAft>
                 <a:spcPts val="1000"/>
               </a:spcAft>
@@ -9083,7 +9083,7 @@
               </a:rPr>
               <a:t>• 26.9%</a:t>
             </a:r>
-            <a:pPr algn="r" indent="0" marL="0">
+            <a:pPr rtl="1" algn="r" indent="0" marL="0">
               <a:spcAft>
                 <a:spcPts val="1000"/>
               </a:spcAft>
@@ -9103,7 +9103,7 @@
             <a:endParaRPr lang="en-US" sz="1900" dirty="0"/>
           </a:p>
           <a:p>
-            <a:pPr algn="r" indent="0" marL="0">
+            <a:pPr rtl="1" algn="r" indent="0" marL="0">
               <a:spcAft>
                 <a:spcPts val="1000"/>
               </a:spcAft>
@@ -9120,7 +9120,7 @@
               </a:rPr>
               <a:t>• 1,000+</a:t>
             </a:r>
-            <a:pPr algn="r" indent="0" marL="0">
+            <a:pPr rtl="1" algn="r" indent="0" marL="0">
               <a:spcAft>
                 <a:spcPts val="1000"/>
               </a:spcAft>
@@ -9140,7 +9140,7 @@
             <a:endParaRPr lang="en-US" sz="1900" dirty="0"/>
           </a:p>
           <a:p>
-            <a:pPr algn="r" indent="0" marL="0">
+            <a:pPr rtl="1" algn="r" indent="0" marL="0">
               <a:spcAft>
                 <a:spcPts val="1000"/>
               </a:spcAft>
@@ -9157,7 +9157,7 @@
               </a:rPr>
               <a:t>• 40%</a:t>
             </a:r>
-            <a:pPr algn="r" indent="0" marL="0">
+            <a:pPr rtl="1" algn="r" indent="0" marL="0">
               <a:spcAft>
                 <a:spcPts val="1000"/>
               </a:spcAft>
@@ -9222,7 +9222,7 @@
           <a:bodyPr wrap="square" lIns="0" tIns="0" rIns="0" bIns="0" rtlCol="0" anchor="ctr"/>
           <a:lstStyle/>
           <a:p>
-            <a:pPr algn="r" indent="0" marL="0">
+            <a:pPr rtl="1" algn="r" indent="0" marL="0">
               <a:buNone/>
             </a:pPr>
             <a:r>
@@ -9410,7 +9410,7 @@
           <a:bodyPr wrap="square" lIns="0" tIns="0" rIns="0" bIns="0" rtlCol="0" anchor="ctr"/>
           <a:lstStyle/>
           <a:p>
-            <a:pPr algn="r" indent="0" marL="0">
+            <a:pPr rtl="1" algn="r" indent="0" marL="0">
               <a:buNone/>
             </a:pPr>
             <a:r>
@@ -9449,7 +9449,7 @@
           <a:bodyPr wrap="square" lIns="0" tIns="0" rIns="0" bIns="0" rtlCol="0" anchor="ctr"/>
           <a:lstStyle/>
           <a:p>
-            <a:pPr algn="r" indent="0" marL="0">
+            <a:pPr rtl="1" algn="r" indent="0" marL="0">
               <a:spcAft>
                 <a:spcPts val="1000"/>
               </a:spcAft>
@@ -9466,7 +9466,7 @@
               </a:rPr>
               <a:t>• התשובה:</a:t>
             </a:r>
-            <a:pPr algn="r" indent="0" marL="0">
+            <a:pPr rtl="1" algn="r" indent="0" marL="0">
               <a:spcAft>
                 <a:spcPts val="1000"/>
               </a:spcAft>
@@ -9486,7 +9486,7 @@
             <a:endParaRPr lang="en-US" sz="1900" dirty="0"/>
           </a:p>
           <a:p>
-            <a:pPr algn="r" indent="0" marL="0">
+            <a:pPr rtl="1" algn="r" indent="0" marL="0">
               <a:spcAft>
                 <a:spcPts val="1000"/>
               </a:spcAft>
@@ -9503,7 +9503,7 @@
               </a:rPr>
               <a:t>• קוד מכונה → שפות עיליות (כמו Python) → IDE + Autocomplete → Git → </a:t>
             </a:r>
-            <a:pPr algn="r" indent="0" marL="0">
+            <a:pPr rtl="1" algn="r" indent="0" marL="0">
               <a:spcAft>
                 <a:spcPts val="1000"/>
               </a:spcAft>
@@ -9523,7 +9523,7 @@
             <a:endParaRPr lang="en-US" sz="1900" dirty="0"/>
           </a:p>
           <a:p>
-            <a:pPr algn="r" indent="0" marL="0">
+            <a:pPr rtl="1" algn="r" indent="0" marL="0">
               <a:spcAft>
                 <a:spcPts val="1000"/>
               </a:spcAft>
@@ -9588,7 +9588,7 @@
           <a:bodyPr wrap="square" lIns="0" tIns="0" rIns="0" bIns="0" rtlCol="0" anchor="ctr"/>
           <a:lstStyle/>
           <a:p>
-            <a:pPr algn="r" indent="0" marL="0">
+            <a:pPr rtl="1" algn="r" indent="0" marL="0">
               <a:buNone/>
             </a:pPr>
             <a:r>
@@ -9801,7 +9801,7 @@
           <a:bodyPr wrap="square" lIns="0" tIns="0" rIns="0" bIns="0" rtlCol="0" anchor="ctr"/>
           <a:lstStyle/>
           <a:p>
-            <a:pPr algn="r" indent="0" marL="0">
+            <a:pPr rtl="1" algn="r" indent="0" marL="0">
               <a:spcAft>
                 <a:spcPts val="1000"/>
               </a:spcAft>
@@ -9818,7 +9818,7 @@
               </a:rPr>
               <a:t>• IDE ראשונים: </a:t>
             </a:r>
-            <a:pPr algn="r" indent="0" marL="0">
+            <a:pPr rtl="1" algn="r" indent="0" marL="0">
               <a:spcAft>
                 <a:spcPts val="1000"/>
               </a:spcAft>
@@ -9838,7 +9838,7 @@
             <a:endParaRPr lang="en-US" sz="1900" dirty="0"/>
           </a:p>
           <a:p>
-            <a:pPr algn="r" indent="0" marL="0">
+            <a:pPr rtl="1" algn="r" indent="0" marL="0">
               <a:spcAft>
                 <a:spcPts val="1000"/>
               </a:spcAft>
@@ -9855,7 +9855,7 @@
               </a:rPr>
               <a:t>• Git: </a:t>
             </a:r>
-            <a:pPr algn="r" indent="0" marL="0">
+            <a:pPr rtl="1" algn="r" indent="0" marL="0">
               <a:spcAft>
                 <a:spcPts val="1000"/>
               </a:spcAft>
@@ -9872,7 +9872,7 @@
               </a:rPr>
               <a:t>2005</a:t>
             </a:r>
-            <a:pPr algn="r" indent="0" marL="0">
+            <a:pPr rtl="1" algn="r" indent="0" marL="0">
               <a:spcAft>
                 <a:spcPts val="1000"/>
               </a:spcAft>
@@ -9889,7 +9889,7 @@
               </a:rPr>
               <a:t> · GitHub: </a:t>
             </a:r>
-            <a:pPr algn="r" indent="0" marL="0">
+            <a:pPr rtl="1" algn="r" indent="0" marL="0">
               <a:spcAft>
                 <a:spcPts val="1000"/>
               </a:spcAft>
@@ -9909,7 +9909,7 @@
             <a:endParaRPr lang="en-US" sz="1900" dirty="0"/>
           </a:p>
           <a:p>
-            <a:pPr algn="r" indent="0" marL="0">
+            <a:pPr rtl="1" algn="r" indent="0" marL="0">
               <a:spcAft>
                 <a:spcPts val="1000"/>
               </a:spcAft>
@@ -9926,7 +9926,7 @@
               </a:rPr>
               <a:t>• GitHub Copilot (Preview): </a:t>
             </a:r>
-            <a:pPr algn="r" indent="0" marL="0">
+            <a:pPr rtl="1" algn="r" indent="0" marL="0">
               <a:spcAft>
                 <a:spcPts val="1000"/>
               </a:spcAft>
@@ -9946,7 +9946,7 @@
             <a:endParaRPr lang="en-US" sz="1900" dirty="0"/>
           </a:p>
           <a:p>
-            <a:pPr algn="r" indent="0" marL="0">
+            <a:pPr rtl="1" algn="r" indent="0" marL="0">
               <a:spcAft>
                 <a:spcPts val="1000"/>
               </a:spcAft>
@@ -9963,7 +9963,7 @@
               </a:rPr>
               <a:t>• ChatGPT: </a:t>
             </a:r>
-            <a:pPr algn="r" indent="0" marL="0">
+            <a:pPr rtl="1" algn="r" indent="0" marL="0">
               <a:spcAft>
                 <a:spcPts val="1000"/>
               </a:spcAft>
@@ -9983,7 +9983,7 @@
             <a:endParaRPr lang="en-US" sz="1900" dirty="0"/>
           </a:p>
           <a:p>
-            <a:pPr algn="r" indent="0" marL="0">
+            <a:pPr rtl="1" algn="r" indent="0" marL="0">
               <a:spcAft>
                 <a:spcPts val="1000"/>
               </a:spcAft>
@@ -10000,7 +10000,7 @@
               </a:rPr>
               <a:t>• כלים אג'נטיים אמיתיים: </a:t>
             </a:r>
-            <a:pPr algn="r" indent="0" marL="0">
+            <a:pPr rtl="1" algn="r" indent="0" marL="0">
               <a:spcAft>
                 <a:spcPts val="1000"/>
               </a:spcAft>
@@ -10065,7 +10065,7 @@
           <a:bodyPr wrap="square" lIns="0" tIns="0" rIns="0" bIns="0" rtlCol="0" anchor="ctr"/>
           <a:lstStyle/>
           <a:p>
-            <a:pPr algn="r" indent="0" marL="0">
+            <a:pPr rtl="1" algn="r" indent="0" marL="0">
               <a:buNone/>
             </a:pPr>
             <a:r>
@@ -10253,7 +10253,7 @@
           <a:bodyPr wrap="square" lIns="0" tIns="0" rIns="0" bIns="0" rtlCol="0" anchor="ctr"/>
           <a:lstStyle/>
           <a:p>
-            <a:pPr algn="r" indent="0" marL="0">
+            <a:pPr rtl="1" algn="r" indent="0" marL="0">
               <a:buNone/>
             </a:pPr>
             <a:r>
@@ -10292,7 +10292,7 @@
           <a:bodyPr wrap="square" lIns="0" tIns="0" rIns="0" bIns="0" rtlCol="0" anchor="ctr"/>
           <a:lstStyle/>
           <a:p>
-            <a:pPr algn="r" indent="0" marL="0">
+            <a:pPr rtl="1" algn="r" indent="0" marL="0">
               <a:spcAft>
                 <a:spcPts val="1000"/>
               </a:spcAft>
@@ -10309,7 +10309,7 @@
               </a:rPr>
               <a:t>• מהירות:</a:t>
             </a:r>
-            <a:pPr algn="r" indent="0" marL="0">
+            <a:pPr rtl="1" algn="r" indent="0" marL="0">
               <a:spcAft>
                 <a:spcPts val="1000"/>
               </a:spcAft>
@@ -10329,7 +10329,7 @@
             <a:endParaRPr lang="en-US" sz="1900" dirty="0"/>
           </a:p>
           <a:p>
-            <a:pPr algn="r" indent="0" marL="0">
+            <a:pPr rtl="1" algn="r" indent="0" marL="0">
               <a:spcAft>
                 <a:spcPts val="1000"/>
               </a:spcAft>
@@ -10346,7 +10346,7 @@
               </a:rPr>
               <a:t>• נגישות:</a:t>
             </a:r>
-            <a:pPr algn="r" indent="0" marL="0">
+            <a:pPr rtl="1" algn="r" indent="0" marL="0">
               <a:spcAft>
                 <a:spcPts val="1000"/>
               </a:spcAft>
@@ -10366,7 +10366,7 @@
             <a:endParaRPr lang="en-US" sz="1900" dirty="0"/>
           </a:p>
           <a:p>
-            <a:pPr algn="r" indent="0" marL="0">
+            <a:pPr rtl="1" algn="r" indent="0" marL="0">
               <a:spcAft>
                 <a:spcPts val="1000"/>
               </a:spcAft>
@@ -10383,7 +10383,7 @@
               </a:rPr>
               <a:t>• שחרור מבוילרפלייט:</a:t>
             </a:r>
-            <a:pPr algn="r" indent="0" marL="0">
+            <a:pPr rtl="1" algn="r" indent="0" marL="0">
               <a:spcAft>
                 <a:spcPts val="1000"/>
               </a:spcAft>
@@ -10448,7 +10448,7 @@
           <a:bodyPr wrap="square" lIns="0" tIns="0" rIns="0" bIns="0" rtlCol="0" anchor="ctr"/>
           <a:lstStyle/>
           <a:p>
-            <a:pPr algn="r" indent="0" marL="0">
+            <a:pPr rtl="1" algn="r" indent="0" marL="0">
               <a:buNone/>
             </a:pPr>
             <a:r>
@@ -10661,7 +10661,7 @@
           <a:bodyPr wrap="square" lIns="0" tIns="0" rIns="0" bIns="0" rtlCol="0" anchor="ctr"/>
           <a:lstStyle/>
           <a:p>
-            <a:pPr algn="r" indent="0" marL="0">
+            <a:pPr rtl="1" algn="r" indent="0" marL="0">
               <a:buNone/>
             </a:pPr>
             <a:r>
@@ -10700,7 +10700,7 @@
           <a:bodyPr wrap="square" lIns="0" tIns="0" rIns="0" bIns="0" rtlCol="0" anchor="ctr"/>
           <a:lstStyle/>
           <a:p>
-            <a:pPr algn="r" indent="0" marL="0">
+            <a:pPr rtl="1" algn="r" indent="0" marL="0">
               <a:spcAft>
                 <a:spcPts val="1000"/>
               </a:spcAft>
@@ -10720,7 +10720,7 @@
             <a:endParaRPr lang="en-US" sz="1900" dirty="0"/>
           </a:p>
           <a:p>
-            <a:pPr algn="r" indent="0" marL="0">
+            <a:pPr rtl="1" algn="r" indent="0" marL="0">
               <a:spcAft>
                 <a:spcPts val="1000"/>
               </a:spcAft>
@@ -10740,7 +10740,7 @@
             <a:endParaRPr lang="en-US" sz="1900" dirty="0"/>
           </a:p>
           <a:p>
-            <a:pPr algn="r" indent="0" marL="0">
+            <a:pPr rtl="1" algn="r" indent="0" marL="0">
               <a:spcAft>
                 <a:spcPts val="1000"/>
               </a:spcAft>
@@ -10760,7 +10760,7 @@
             <a:endParaRPr lang="en-US" sz="1900" dirty="0"/>
           </a:p>
           <a:p>
-            <a:pPr algn="r" indent="0" marL="0">
+            <a:pPr rtl="1" algn="r" indent="0" marL="0">
               <a:spcAft>
                 <a:spcPts val="1000"/>
               </a:spcAft>
@@ -10777,7 +10777,7 @@
               </a:rPr>
               <a:t>• והבעיה המרכזית שבה נתמקד עכשיו: </a:t>
             </a:r>
-            <a:pPr algn="r" indent="0" marL="0">
+            <a:pPr rtl="1" algn="r" indent="0" marL="0">
               <a:spcAft>
                 <a:spcPts val="1000"/>
               </a:spcAft>
@@ -10842,7 +10842,7 @@
           <a:bodyPr wrap="square" lIns="0" tIns="0" rIns="0" bIns="0" rtlCol="0" anchor="ctr"/>
           <a:lstStyle/>
           <a:p>
-            <a:pPr algn="r" indent="0" marL="0">
+            <a:pPr rtl="1" algn="r" indent="0" marL="0">
               <a:buNone/>
             </a:pPr>
             <a:r>

</xml_diff>

<commit_message>
גלוסה מלאה לכל מונחי ז'רגון בשיעור 1 (IDE, Git, GitHub, API, CLI, Context, Token, Deloitte, Copilot Student, localStorage)
- סגירת פרצה בפרומפט האב: הפניה עתידית ('נסביר בשיעור הבא') כבר לא
  יכולה להחליף גלוסה מיידית - רק להוסיף עליה
- תוקן שקף Evolution ושקף ציר-הזמן: IDE, Git, GitHub, Autocomplete,
  AI Agentic מקבלים כולם הסבר קצר בסוגריים בהופעה הראשונה
- עודכן: slides.md, build_deck.js, lesson.md, lesson_01_slides.pptx
- נבדק RTL מחדש: 257/257 pPr blocks עם rtl="1"
</commit_message>
<xml_diff>
--- a/lesson_01/lesson_01_slides.pptx
+++ b/lesson_01/lesson_01_slides.pptx
@@ -3271,7 +3271,41 @@
                 <a:ea typeface="Calibri" pitchFamily="34" charset="-122"/>
                 <a:cs typeface="Calibri" pitchFamily="34" charset="-120"/>
               </a:rPr>
-              <a:t>• הוא ממשיך "לנחש" את הטקסט הכי סביר — גם אם זה אומר להמציא פונקציה, ספרייה, או API שלא קיימים</a:t>
+              <a:t>• הוא ממשיך "לנחש" את הטקסט הכי סביר — גם אם זה אומר להמציא פונקציה, ספרייה, או </a:t>
+            </a:r>
+            <a:pPr rtl="1" algn="r" indent="0" marL="0">
+              <a:spcAft>
+                <a:spcPts val="1000"/>
+              </a:spcAft>
+              <a:buNone/>
+            </a:pPr>
+            <a:r>
+              <a:rPr lang="en-US" sz="1900" b="1" dirty="0">
+                <a:solidFill>
+                  <a:srgbClr val="1B1F3B"/>
+                </a:solidFill>
+                <a:latin typeface="Calibri" pitchFamily="34" charset="0"/>
+                <a:ea typeface="Calibri" pitchFamily="34" charset="-122"/>
+                <a:cs typeface="Calibri" pitchFamily="34" charset="-120"/>
+              </a:rPr>
+              <a:t>API</a:t>
+            </a:r>
+            <a:pPr rtl="1" algn="r" indent="0" marL="0">
+              <a:spcAft>
+                <a:spcPts val="1000"/>
+              </a:spcAft>
+              <a:buNone/>
+            </a:pPr>
+            <a:r>
+              <a:rPr lang="en-US" sz="1900" dirty="0">
+                <a:solidFill>
+                  <a:srgbClr val="1B1F3B"/>
+                </a:solidFill>
+                <a:latin typeface="Calibri" pitchFamily="34" charset="0"/>
+                <a:ea typeface="Calibri" pitchFamily="34" charset="-122"/>
+                <a:cs typeface="Calibri" pitchFamily="34" charset="-120"/>
+              </a:rPr>
+              <a:t> (ממשק שדרכו תוכנות מדברות זו עם זו) שלא קיימים</a:t>
             </a:r>
             <a:endParaRPr lang="en-US" sz="1900" dirty="0"/>
           </a:p>
@@ -5737,7 +5771,41 @@
                 <a:ea typeface="Calibri" pitchFamily="34" charset="-122"/>
                 <a:cs typeface="Calibri" pitchFamily="34" charset="-120"/>
               </a:rPr>
-              <a:t>• Google הריצה כלי CLI חינמי — Gemini CLI</a:t>
+              <a:t>• Google הריצה כלי </a:t>
+            </a:r>
+            <a:pPr rtl="1" algn="r" indent="0" marL="0">
+              <a:spcAft>
+                <a:spcPts val="1000"/>
+              </a:spcAft>
+              <a:buNone/>
+            </a:pPr>
+            <a:r>
+              <a:rPr lang="en-US" sz="1900" b="1" dirty="0">
+                <a:solidFill>
+                  <a:srgbClr val="1B1F3B"/>
+                </a:solidFill>
+                <a:latin typeface="Calibri" pitchFamily="34" charset="0"/>
+                <a:ea typeface="Calibri" pitchFamily="34" charset="-122"/>
+                <a:cs typeface="Calibri" pitchFamily="34" charset="-120"/>
+              </a:rPr>
+              <a:t>CLI</a:t>
+            </a:r>
+            <a:pPr rtl="1" algn="r" indent="0" marL="0">
+              <a:spcAft>
+                <a:spcPts val="1000"/>
+              </a:spcAft>
+              <a:buNone/>
+            </a:pPr>
+            <a:r>
+              <a:rPr lang="en-US" sz="1900" dirty="0">
+                <a:solidFill>
+                  <a:srgbClr val="1B1F3B"/>
+                </a:solidFill>
+                <a:latin typeface="Calibri" pitchFamily="34" charset="0"/>
+                <a:ea typeface="Calibri" pitchFamily="34" charset="-122"/>
+                <a:cs typeface="Calibri" pitchFamily="34" charset="-120"/>
+              </a:rPr>
+              <a:t> (ממשק שורת-פקודה — עובדים דרך הקלדת פקודות טקסט, בלי עכבר) חינמי — Gemini CLI</a:t>
             </a:r>
             <a:endParaRPr lang="en-US" sz="1900" dirty="0"/>
           </a:p>
@@ -6148,7 +6216,41 @@
                 <a:ea typeface="Calibri" pitchFamily="34" charset="-122"/>
                 <a:cs typeface="Calibri" pitchFamily="34" charset="-120"/>
               </a:rPr>
-              <a:t> (הפלטפורמה המרכזית בעולם לאחסון ושיתוף קוד — נסביר עליה לעומק בשיעור הבא) שינה את מסלול הסטודנטים ל-Copilot Student</a:t>
+              <a:t> (הפלטפורמה המרכזית בעולם לאחסון ושיתוף קוד — נסביר עליה לעומק בשיעור הבא) שינה את מסלול הסטודנטים ל-</a:t>
+            </a:r>
+            <a:pPr rtl="1" algn="r" indent="0" marL="0">
+              <a:spcAft>
+                <a:spcPts val="1000"/>
+              </a:spcAft>
+              <a:buNone/>
+            </a:pPr>
+            <a:r>
+              <a:rPr lang="en-US" sz="1900" b="1" dirty="0">
+                <a:solidFill>
+                  <a:srgbClr val="1B1F3B"/>
+                </a:solidFill>
+                <a:latin typeface="Calibri" pitchFamily="34" charset="0"/>
+                <a:ea typeface="Calibri" pitchFamily="34" charset="-122"/>
+                <a:cs typeface="Calibri" pitchFamily="34" charset="-120"/>
+              </a:rPr>
+              <a:t>Copilot Student</a:t>
+            </a:r>
+            <a:pPr rtl="1" algn="r" indent="0" marL="0">
+              <a:spcAft>
+                <a:spcPts val="1000"/>
+              </a:spcAft>
+              <a:buNone/>
+            </a:pPr>
+            <a:r>
+              <a:rPr lang="en-US" sz="1900" dirty="0">
+                <a:solidFill>
+                  <a:srgbClr val="1B1F3B"/>
+                </a:solidFill>
+                <a:latin typeface="Calibri" pitchFamily="34" charset="0"/>
+                <a:ea typeface="Calibri" pitchFamily="34" charset="-122"/>
+                <a:cs typeface="Calibri" pitchFamily="34" charset="-120"/>
+              </a:rPr>
+              <a:t> (התוכנית שנותנת לסטודנטים גישה חינמית ל-GitHub Copilot)</a:t>
             </a:r>
             <a:endParaRPr lang="en-US" sz="1900" dirty="0"/>
           </a:p>
@@ -7173,7 +7275,41 @@
                 <a:ea typeface="Calibri" pitchFamily="34" charset="-122"/>
                 <a:cs typeface="Calibri" pitchFamily="34" charset="-120"/>
               </a:rPr>
-              <a:t>• לא "מבין" כמו בן אדם — מנבא Token אחר Token מה סביר לבוא בהמשך</a:t>
+              <a:t>• לא "מבין" כמו בן אדם — מנבא </a:t>
+            </a:r>
+            <a:pPr rtl="1" algn="r" indent="0" marL="0">
+              <a:spcAft>
+                <a:spcPts val="1000"/>
+              </a:spcAft>
+              <a:buNone/>
+            </a:pPr>
+            <a:r>
+              <a:rPr lang="en-US" sz="1900" b="1" dirty="0">
+                <a:solidFill>
+                  <a:srgbClr val="1B1F3B"/>
+                </a:solidFill>
+                <a:latin typeface="Calibri" pitchFamily="34" charset="0"/>
+                <a:ea typeface="Calibri" pitchFamily="34" charset="-122"/>
+                <a:cs typeface="Calibri" pitchFamily="34" charset="-120"/>
+              </a:rPr>
+              <a:t>Token</a:t>
+            </a:r>
+            <a:pPr rtl="1" algn="r" indent="0" marL="0">
+              <a:spcAft>
+                <a:spcPts val="1000"/>
+              </a:spcAft>
+              <a:buNone/>
+            </a:pPr>
+            <a:r>
+              <a:rPr lang="en-US" sz="1900" dirty="0">
+                <a:solidFill>
+                  <a:srgbClr val="1B1F3B"/>
+                </a:solidFill>
+                <a:latin typeface="Calibri" pitchFamily="34" charset="0"/>
+                <a:ea typeface="Calibri" pitchFamily="34" charset="-122"/>
+                <a:cs typeface="Calibri" pitchFamily="34" charset="-120"/>
+              </a:rPr>
+              <a:t> (יחידת טקסט קטנה: מילה או חלק ממילה) אחר Token מה סביר לבוא בהמשך</a:t>
             </a:r>
             <a:endParaRPr lang="en-US" sz="1900" dirty="0"/>
           </a:p>
@@ -7593,7 +7729,7 @@
                 <a:ea typeface="Calibri" pitchFamily="34" charset="-122"/>
                 <a:cs typeface="Calibri" pitchFamily="34" charset="-120"/>
               </a:rPr>
-              <a:t>• שמירה עם localStorage</a:t>
+              <a:t>• שמירה עם localStorage (זיכרון מקומי בדפדפן שנשמר גם אחרי רענון הדף)</a:t>
             </a:r>
             <a:endParaRPr lang="en-US" sz="1800" dirty="0"/>
           </a:p>
@@ -9274,7 +9410,41 @@
                 <a:ea typeface="Calibri" pitchFamily="34" charset="-122"/>
                 <a:cs typeface="Calibri" pitchFamily="34" charset="-120"/>
               </a:rPr>
-              <a:t> מהאפליקציות הארגוניות — סוכני AI אוטונומיים עד סוף 2026 (מ-5% ב-2025, Deloitte)</a:t>
+              <a:t> מהאפליקציות הארגוניות — סוכני AI אוטונומיים עד סוף 2026 (מ-5% ב-2025, לפי </a:t>
+            </a:r>
+            <a:pPr rtl="1" algn="r" indent="0" marL="0">
+              <a:spcAft>
+                <a:spcPts val="1000"/>
+              </a:spcAft>
+              <a:buNone/>
+            </a:pPr>
+            <a:r>
+              <a:rPr lang="en-US" sz="1900" b="1" dirty="0">
+                <a:solidFill>
+                  <a:srgbClr val="1B1F3B"/>
+                </a:solidFill>
+                <a:latin typeface="Calibri" pitchFamily="34" charset="0"/>
+                <a:ea typeface="Calibri" pitchFamily="34" charset="-122"/>
+                <a:cs typeface="Calibri" pitchFamily="34" charset="-120"/>
+              </a:rPr>
+              <a:t>Deloitte</a:t>
+            </a:r>
+            <a:pPr rtl="1" algn="r" indent="0" marL="0">
+              <a:spcAft>
+                <a:spcPts val="1000"/>
+              </a:spcAft>
+              <a:buNone/>
+            </a:pPr>
+            <a:r>
+              <a:rPr lang="en-US" sz="1900" dirty="0">
+                <a:solidFill>
+                  <a:srgbClr val="1B1F3B"/>
+                </a:solidFill>
+                <a:latin typeface="Calibri" pitchFamily="34" charset="0"/>
+                <a:ea typeface="Calibri" pitchFamily="34" charset="-122"/>
+                <a:cs typeface="Calibri" pitchFamily="34" charset="-120"/>
+              </a:rPr>
+              <a:t> — חברת ייעוץ עסקי בינלאומית גדולה)</a:t>
             </a:r>
             <a:endParaRPr lang="en-US" sz="1900" dirty="0"/>
           </a:p>
@@ -9603,7 +9773,7 @@
                 <a:ea typeface="Calibri" pitchFamily="34" charset="-122"/>
                 <a:cs typeface="Calibri" pitchFamily="34" charset="-120"/>
               </a:rPr>
-              <a:t>• קוד מכונה → שפות עיליות (כמו Python) → IDE + Autocomplete → Git → </a:t>
+              <a:t>• קוד מכונה → שפות עיליות (כמו Python) → </a:t>
             </a:r>
             <a:pPr rtl="1" algn="r" indent="0" marL="0">
               <a:spcAft>
@@ -9620,8 +9790,93 @@
                 <a:ea typeface="Calibri" pitchFamily="34" charset="-122"/>
                 <a:cs typeface="Calibri" pitchFamily="34" charset="-120"/>
               </a:rPr>
+              <a:t>IDE</a:t>
+            </a:r>
+            <a:pPr rtl="1" algn="r" indent="0" marL="0">
+              <a:spcAft>
+                <a:spcPts val="1000"/>
+              </a:spcAft>
+              <a:buNone/>
+            </a:pPr>
+            <a:r>
+              <a:rPr lang="en-US" sz="1900" dirty="0">
+                <a:solidFill>
+                  <a:srgbClr val="1B1F3B"/>
+                </a:solidFill>
+                <a:latin typeface="Calibri" pitchFamily="34" charset="0"/>
+                <a:ea typeface="Calibri" pitchFamily="34" charset="-122"/>
+                <a:cs typeface="Calibri" pitchFamily="34" charset="-120"/>
+              </a:rPr>
+              <a:t> (תוכנה אחת לכתיבה, הרצה ובדיקה של קוד) ו-Autocomplete (השלמה אוטומטית של קוד) → </a:t>
+            </a:r>
+            <a:pPr rtl="1" algn="r" indent="0" marL="0">
+              <a:spcAft>
+                <a:spcPts val="1000"/>
+              </a:spcAft>
+              <a:buNone/>
+            </a:pPr>
+            <a:r>
+              <a:rPr lang="en-US" sz="1900" b="1" dirty="0">
+                <a:solidFill>
+                  <a:srgbClr val="1B1F3B"/>
+                </a:solidFill>
+                <a:latin typeface="Calibri" pitchFamily="34" charset="0"/>
+                <a:ea typeface="Calibri" pitchFamily="34" charset="-122"/>
+                <a:cs typeface="Calibri" pitchFamily="34" charset="-120"/>
+              </a:rPr>
+              <a:t>Git</a:t>
+            </a:r>
+            <a:pPr rtl="1" algn="r" indent="0" marL="0">
+              <a:spcAft>
+                <a:spcPts val="1000"/>
+              </a:spcAft>
+              <a:buNone/>
+            </a:pPr>
+            <a:r>
+              <a:rPr lang="en-US" sz="1900" dirty="0">
+                <a:solidFill>
+                  <a:srgbClr val="1B1F3B"/>
+                </a:solidFill>
+                <a:latin typeface="Calibri" pitchFamily="34" charset="0"/>
+                <a:ea typeface="Calibri" pitchFamily="34" charset="-122"/>
+                <a:cs typeface="Calibri" pitchFamily="34" charset="-120"/>
+              </a:rPr>
+              <a:t> (מערכת לשמירת היסטוריית שינויים בקוד) → </a:t>
+            </a:r>
+            <a:pPr rtl="1" algn="r" indent="0" marL="0">
+              <a:spcAft>
+                <a:spcPts val="1000"/>
+              </a:spcAft>
+              <a:buNone/>
+            </a:pPr>
+            <a:r>
+              <a:rPr lang="en-US" sz="1900" b="1" dirty="0">
+                <a:solidFill>
+                  <a:srgbClr val="1B1F3B"/>
+                </a:solidFill>
+                <a:latin typeface="Calibri" pitchFamily="34" charset="0"/>
+                <a:ea typeface="Calibri" pitchFamily="34" charset="-122"/>
+                <a:cs typeface="Calibri" pitchFamily="34" charset="-120"/>
+              </a:rPr>
               <a:t>AI Agentic</a:t>
             </a:r>
+            <a:pPr rtl="1" algn="r" indent="0" marL="0">
+              <a:spcAft>
+                <a:spcPts val="1000"/>
+              </a:spcAft>
+              <a:buNone/>
+            </a:pPr>
+            <a:r>
+              <a:rPr lang="en-US" sz="1900" dirty="0">
+                <a:solidFill>
+                  <a:srgbClr val="1B1F3B"/>
+                </a:solidFill>
+                <a:latin typeface="Calibri" pitchFamily="34" charset="0"/>
+                <a:ea typeface="Calibri" pitchFamily="34" charset="-122"/>
+                <a:cs typeface="Calibri" pitchFamily="34" charset="-120"/>
+              </a:rPr>
+              <a:t> (AI שפועל עצמאית על משימה שלמה, לא רק עונה לשאלה)</a:t>
+            </a:r>
             <a:endParaRPr lang="en-US" sz="1900" dirty="0"/>
           </a:p>
           <a:p>
@@ -9640,7 +9895,7 @@
                 <a:ea typeface="Calibri" pitchFamily="34" charset="-122"/>
                 <a:cs typeface="Calibri" pitchFamily="34" charset="-120"/>
               </a:rPr>
-              <a:t>• כל קפיצה שינתה מה נחשב "עבודה של מפתח" — ולא נעצרה. את IDE, Git ו-Autocomplete נסביר לעומק בשיעור הבא</a:t>
+              <a:t>• כל קפיצה שינתה מה נחשב "עבודה של מפתח" — ולא נעצרה (נעמיק בכל כלי לאורך הקורס)</a:t>
             </a:r>
             <a:endParaRPr lang="en-US" sz="1900" dirty="0"/>
           </a:p>
@@ -9918,7 +10173,7 @@
                 <a:ea typeface="Calibri" pitchFamily="34" charset="-122"/>
                 <a:cs typeface="Calibri" pitchFamily="34" charset="-120"/>
               </a:rPr>
-              <a:t>• IDE ראשונים: </a:t>
+              <a:t>• IDE (סביבת פיתוח לכתיבת קוד — ראינו בשקף הקודם) ראשונים: </a:t>
             </a:r>
             <a:pPr rtl="1" algn="r" indent="0" marL="0">
               <a:spcAft>
@@ -9955,7 +10210,7 @@
                 <a:ea typeface="Calibri" pitchFamily="34" charset="-122"/>
                 <a:cs typeface="Calibri" pitchFamily="34" charset="-120"/>
               </a:rPr>
-              <a:t>• Git: </a:t>
+              <a:t>• Git (ניהול גרסאות קוד): </a:t>
             </a:r>
             <a:pPr rtl="1" algn="r" indent="0" marL="0">
               <a:spcAft>
@@ -9989,7 +10244,7 @@
                 <a:ea typeface="Calibri" pitchFamily="34" charset="-122"/>
                 <a:cs typeface="Calibri" pitchFamily="34" charset="-120"/>
               </a:rPr>
-              <a:t> · GitHub: </a:t>
+              <a:t> · GitHub (פלטפורמה לאחסון ושיתוף קוד, מבוססת Git): </a:t>
             </a:r>
             <a:pPr rtl="1" algn="r" indent="0" marL="0">
               <a:spcAft>
@@ -10026,7 +10281,7 @@
                 <a:ea typeface="Calibri" pitchFamily="34" charset="-122"/>
                 <a:cs typeface="Calibri" pitchFamily="34" charset="-120"/>
               </a:rPr>
-              <a:t>• GitHub Copilot (Preview): </a:t>
+              <a:t>• GitHub Copilot (עוזר AI לכתיבת קוד) בגרסת Preview (תצוגה מקדימה): </a:t>
             </a:r>
             <a:pPr rtl="1" algn="r" indent="0" marL="0">
               <a:spcAft>
@@ -10100,7 +10355,7 @@
                 <a:ea typeface="Calibri" pitchFamily="34" charset="-122"/>
                 <a:cs typeface="Calibri" pitchFamily="34" charset="-120"/>
               </a:rPr>
-              <a:t>• כלים אג'נטיים אמיתיים: </a:t>
+              <a:t>• כלים אג'נטיים אמיתיים (AI שפועל עצמאית על משימה שלמה): </a:t>
             </a:r>
             <a:pPr rtl="1" algn="r" indent="0" marL="0">
               <a:spcAft>
@@ -10817,7 +11072,41 @@
                 <a:ea typeface="Calibri" pitchFamily="34" charset="-122"/>
                 <a:cs typeface="Calibri" pitchFamily="34" charset="-120"/>
               </a:rPr>
-              <a:t>• שוכח הקשר בלי Context מנוהל (נעמיק בשיעור 3)</a:t>
+              <a:t>• שוכח הקשר בלי </a:t>
+            </a:r>
+            <a:pPr rtl="1" algn="r" indent="0" marL="0">
+              <a:spcAft>
+                <a:spcPts val="1000"/>
+              </a:spcAft>
+              <a:buNone/>
+            </a:pPr>
+            <a:r>
+              <a:rPr lang="en-US" sz="1900" b="1" dirty="0">
+                <a:solidFill>
+                  <a:srgbClr val="1B1F3B"/>
+                </a:solidFill>
+                <a:latin typeface="Calibri" pitchFamily="34" charset="0"/>
+                <a:ea typeface="Calibri" pitchFamily="34" charset="-122"/>
+                <a:cs typeface="Calibri" pitchFamily="34" charset="-120"/>
+              </a:rPr>
+              <a:t>Context</a:t>
+            </a:r>
+            <a:pPr rtl="1" algn="r" indent="0" marL="0">
+              <a:spcAft>
+                <a:spcPts val="1000"/>
+              </a:spcAft>
+              <a:buNone/>
+            </a:pPr>
+            <a:r>
+              <a:rPr lang="en-US" sz="1900" dirty="0">
+                <a:solidFill>
+                  <a:srgbClr val="1B1F3B"/>
+                </a:solidFill>
+                <a:latin typeface="Calibri" pitchFamily="34" charset="0"/>
+                <a:ea typeface="Calibri" pitchFamily="34" charset="-122"/>
+                <a:cs typeface="Calibri" pitchFamily="34" charset="-120"/>
+              </a:rPr>
+              <a:t> (המידע שה-AI 'זוכר' על הפרויקט) מנוהל (נעמיק בשיעור 3)</a:t>
             </a:r>
             <a:endParaRPr lang="en-US" sz="1900" dirty="0"/>
           </a:p>

</xml_diff>